<commit_message>
Fix author emails and deck layout issues
- Paper: replace placeholder emails with smsagrado@up.edu.ph and
  jjdonaire@up.edu.ph
- Deck slide 12 (Discussion): split bullets and scenario-compare figure
  into clean left/right columns to stop the figure from clipping the
  bullet text
- Deck slide 2 (Hook): remove the accent line under the subtitle
</commit_message>
<xml_diff>
--- a/presentation/PARCHED_final.pptx
+++ b/presentation/PARCHED_final.pptx
@@ -5663,8 +5663,8 @@
         </p:nvSpPr>
         <p:spPr>
           <a:xfrm>
-            <a:off x="700000" y="1600000"/>
-            <a:ext cx="7800000" cy="5000000"/>
+            <a:off x="700000" y="1700000"/>
+            <a:ext cx="6500000" cy="5000000"/>
           </a:xfrm>
           <a:prstGeom prst="rect">
             <a:avLst/>
@@ -5683,7 +5683,7 @@
               </a:lnSpc>
             </a:pPr>
             <a:r>
-              <a:rPr sz="2000" b="1">
+              <a:rPr sz="1800" b="1">
                 <a:solidFill>
                   <a:srgbClr val="3EE6C5"/>
                 </a:solidFill>
@@ -5692,7 +5692,7 @@
               <a:t>▸  </a:t>
             </a:r>
             <a:r>
-              <a:rPr sz="2000">
+              <a:rPr sz="1800">
                 <a:solidFill>
                   <a:srgbClr val="FFFFFF"/>
                 </a:solidFill>
@@ -5708,7 +5708,7 @@
               </a:lnSpc>
             </a:pPr>
             <a:r>
-              <a:rPr sz="2000" b="1">
+              <a:rPr sz="1800" b="1">
                 <a:solidFill>
                   <a:srgbClr val="3EE6C5"/>
                 </a:solidFill>
@@ -5717,7 +5717,7 @@
               <a:t>▸  </a:t>
             </a:r>
             <a:r>
-              <a:rPr sz="2000">
+              <a:rPr sz="1800">
                 <a:solidFill>
                   <a:srgbClr val="FFFFFF"/>
                 </a:solidFill>
@@ -5733,7 +5733,7 @@
               </a:lnSpc>
             </a:pPr>
             <a:r>
-              <a:rPr sz="2000" b="1">
+              <a:rPr sz="1800" b="1">
                 <a:solidFill>
                   <a:srgbClr val="3EE6C5"/>
                 </a:solidFill>
@@ -5742,7 +5742,7 @@
               <a:t>▸  </a:t>
             </a:r>
             <a:r>
-              <a:rPr sz="2000">
+              <a:rPr sz="1800">
                 <a:solidFill>
                   <a:srgbClr val="FFFFFF"/>
                 </a:solidFill>
@@ -5758,7 +5758,7 @@
               </a:lnSpc>
             </a:pPr>
             <a:r>
-              <a:rPr sz="2000" b="1">
+              <a:rPr sz="1800" b="1">
                 <a:solidFill>
                   <a:srgbClr val="3EE6C5"/>
                 </a:solidFill>
@@ -5767,7 +5767,7 @@
               <a:t>▸  </a:t>
             </a:r>
             <a:r>
-              <a:rPr sz="2000">
+              <a:rPr sz="1800">
                 <a:solidFill>
                   <a:srgbClr val="FFFFFF"/>
                 </a:solidFill>
@@ -5794,8 +5794,8 @@
         </p:blipFill>
         <p:spPr>
           <a:xfrm>
-            <a:off x="8133333" y="1700000"/>
-            <a:ext cx="4500000" cy="3321330"/>
+            <a:off x="7700000" y="1700000"/>
+            <a:ext cx="5033333" cy="3714969"/>
           </a:xfrm>
           <a:prstGeom prst="rect">
             <a:avLst/>
@@ -5810,8 +5810,8 @@
         </p:nvSpPr>
         <p:spPr>
           <a:xfrm>
-            <a:off x="8133333" y="5071330"/>
-            <a:ext cx="4500000" cy="400000"/>
+            <a:off x="7700000" y="5464969"/>
+            <a:ext cx="5033333" cy="400000"/>
           </a:xfrm>
           <a:prstGeom prst="rect">
             <a:avLst/>
@@ -7143,50 +7143,7 @@
       </p:sp>
       <p:sp>
         <p:nvSpPr>
-          <p:cNvPr id="6" name="Rectangle 5"/>
-          <p:cNvSpPr/>
-          <p:nvPr/>
-        </p:nvSpPr>
-        <p:spPr>
-          <a:xfrm>
-            <a:off x="700000" y="4600000"/>
-            <a:ext cx="1200000" cy="30000"/>
-          </a:xfrm>
-          <a:prstGeom prst="rect">
-            <a:avLst/>
-          </a:prstGeom>
-          <a:solidFill>
-            <a:srgbClr val="E6A532"/>
-          </a:solidFill>
-          <a:ln>
-            <a:noFill/>
-          </a:ln>
-        </p:spPr>
-        <p:style>
-          <a:lnRef idx="1">
-            <a:schemeClr val="accent1"/>
-          </a:lnRef>
-          <a:fillRef idx="3">
-            <a:schemeClr val="accent1"/>
-          </a:fillRef>
-          <a:effectRef idx="2">
-            <a:schemeClr val="accent1"/>
-          </a:effectRef>
-          <a:fontRef idx="minor">
-            <a:schemeClr val="lt1"/>
-          </a:fontRef>
-        </p:style>
-        <p:txBody>
-          <a:bodyPr rtlCol="0" anchor="ctr"/>
-          <a:lstStyle/>
-          <a:p>
-            <a:pPr algn="ctr"/>
-          </a:p>
-        </p:txBody>
-      </p:sp>
-      <p:sp>
-        <p:nvSpPr>
-          <p:cNvPr id="7" name="TextBox 6"/>
+          <p:cNvPr id="6" name="TextBox 5"/>
           <p:cNvSpPr txBox="1"/>
           <p:nvPr/>
         </p:nvSpPr>
@@ -7221,7 +7178,7 @@
       </p:sp>
       <p:sp>
         <p:nvSpPr>
-          <p:cNvPr id="8" name="TextBox 7"/>
+          <p:cNvPr id="7" name="TextBox 6"/>
           <p:cNvSpPr txBox="1"/>
           <p:nvPr/>
         </p:nvSpPr>
@@ -7256,7 +7213,7 @@
       </p:sp>
       <p:sp>
         <p:nvSpPr>
-          <p:cNvPr id="9" name="TextBox 8"/>
+          <p:cNvPr id="8" name="TextBox 7"/>
           <p:cNvSpPr txBox="1"/>
           <p:nvPr/>
         </p:nvSpPr>

</xml_diff>

<commit_message>
Swap deck accent from burnt-orange to deep maroon
</commit_message>
<xml_diff>
--- a/presentation/PARCHED_final.pptx
+++ b/presentation/PARCHED_final.pptx
@@ -4465,7 +4465,7 @@
             <a:r>
               <a:rPr sz="1100" b="1" i="0">
                 <a:solidFill>
-                  <a:srgbClr val="C15F3C"/>
+                  <a:srgbClr val="7B2D26"/>
                 </a:solidFill>
                 <a:latin typeface="Helvetica Neue"/>
               </a:rPr>
@@ -4842,7 +4842,7 @@
             <a:avLst/>
           </a:prstGeom>
           <a:solidFill>
-            <a:srgbClr val="C15F3C"/>
+            <a:srgbClr val="7B2D26"/>
           </a:solidFill>
           <a:ln>
             <a:noFill/>
@@ -4955,7 +4955,7 @@
             <a:r>
               <a:rPr sz="1100" b="1" i="0">
                 <a:solidFill>
-                  <a:srgbClr val="C15F3C"/>
+                  <a:srgbClr val="7B2D26"/>
                 </a:solidFill>
                 <a:latin typeface="Helvetica Neue"/>
               </a:rPr>
@@ -4990,7 +4990,7 @@
             <a:r>
               <a:rPr sz="7200" b="1" i="0">
                 <a:solidFill>
-                  <a:srgbClr val="C15F3C"/>
+                  <a:srgbClr val="7B2D26"/>
                 </a:solidFill>
                 <a:latin typeface="Georgia"/>
               </a:rPr>
@@ -5250,7 +5250,7 @@
             <a:avLst/>
           </a:prstGeom>
           <a:solidFill>
-            <a:srgbClr val="C15F3C"/>
+            <a:srgbClr val="7B2D26"/>
           </a:solidFill>
           <a:ln>
             <a:noFill/>
@@ -5363,7 +5363,7 @@
             <a:r>
               <a:rPr sz="1100" b="1" i="0">
                 <a:solidFill>
-                  <a:srgbClr val="C15F3C"/>
+                  <a:srgbClr val="7B2D26"/>
                 </a:solidFill>
                 <a:latin typeface="Helvetica Neue"/>
               </a:rPr>
@@ -5398,7 +5398,7 @@
             <a:r>
               <a:rPr sz="6000" b="1" i="0">
                 <a:solidFill>
-                  <a:srgbClr val="C15F3C"/>
+                  <a:srgbClr val="7B2D26"/>
                 </a:solidFill>
                 <a:latin typeface="Georgia"/>
               </a:rPr>
@@ -5693,7 +5693,7 @@
             <a:avLst/>
           </a:prstGeom>
           <a:solidFill>
-            <a:srgbClr val="C15F3C"/>
+            <a:srgbClr val="7B2D26"/>
           </a:solidFill>
           <a:ln>
             <a:noFill/>
@@ -5786,7 +5786,7 @@
             <a:r>
               <a:rPr sz="1400" b="1">
                 <a:solidFill>
-                  <a:srgbClr val="C15F3C"/>
+                  <a:srgbClr val="7B2D26"/>
                 </a:solidFill>
                 <a:latin typeface="Helvetica Neue"/>
               </a:rPr>
@@ -5811,7 +5811,7 @@
             <a:r>
               <a:rPr sz="1400" b="1">
                 <a:solidFill>
-                  <a:srgbClr val="C15F3C"/>
+                  <a:srgbClr val="7B2D26"/>
                 </a:solidFill>
                 <a:latin typeface="Helvetica Neue"/>
               </a:rPr>
@@ -5836,7 +5836,7 @@
             <a:r>
               <a:rPr sz="1400" b="1">
                 <a:solidFill>
-                  <a:srgbClr val="C15F3C"/>
+                  <a:srgbClr val="7B2D26"/>
                 </a:solidFill>
                 <a:latin typeface="Helvetica Neue"/>
               </a:rPr>
@@ -5861,7 +5861,7 @@
             <a:r>
               <a:rPr sz="1400" b="1">
                 <a:solidFill>
-                  <a:srgbClr val="C15F3C"/>
+                  <a:srgbClr val="7B2D26"/>
                 </a:solidFill>
                 <a:latin typeface="Helvetica Neue"/>
               </a:rPr>
@@ -6049,7 +6049,7 @@
             <a:avLst/>
           </a:prstGeom>
           <a:solidFill>
-            <a:srgbClr val="C15F3C"/>
+            <a:srgbClr val="7B2D26"/>
           </a:solidFill>
           <a:ln>
             <a:noFill/>
@@ -6138,7 +6138,7 @@
             <a:r>
               <a:rPr sz="1100" b="1" i="0">
                 <a:solidFill>
-                  <a:srgbClr val="C15F3C"/>
+                  <a:srgbClr val="7B2D26"/>
                 </a:solidFill>
                 <a:latin typeface="Helvetica Neue"/>
               </a:rPr>
@@ -6177,7 +6177,7 @@
             <a:r>
               <a:rPr sz="1300" b="1">
                 <a:solidFill>
-                  <a:srgbClr val="C15F3C"/>
+                  <a:srgbClr val="7B2D26"/>
                 </a:solidFill>
                 <a:latin typeface="Helvetica Neue"/>
               </a:rPr>
@@ -6202,7 +6202,7 @@
             <a:r>
               <a:rPr sz="1300" b="1">
                 <a:solidFill>
-                  <a:srgbClr val="C15F3C"/>
+                  <a:srgbClr val="7B2D26"/>
                 </a:solidFill>
                 <a:latin typeface="Helvetica Neue"/>
               </a:rPr>
@@ -6227,7 +6227,7 @@
             <a:r>
               <a:rPr sz="1300" b="1">
                 <a:solidFill>
-                  <a:srgbClr val="C15F3C"/>
+                  <a:srgbClr val="7B2D26"/>
                 </a:solidFill>
                 <a:latin typeface="Helvetica Neue"/>
               </a:rPr>
@@ -6252,7 +6252,7 @@
             <a:r>
               <a:rPr sz="1300" b="1">
                 <a:solidFill>
-                  <a:srgbClr val="C15F3C"/>
+                  <a:srgbClr val="7B2D26"/>
                 </a:solidFill>
                 <a:latin typeface="Helvetica Neue"/>
               </a:rPr>
@@ -6277,7 +6277,7 @@
             <a:r>
               <a:rPr sz="1300" b="1">
                 <a:solidFill>
-                  <a:srgbClr val="C15F3C"/>
+                  <a:srgbClr val="7B2D26"/>
                 </a:solidFill>
                 <a:latin typeface="Helvetica Neue"/>
               </a:rPr>
@@ -6302,7 +6302,7 @@
             <a:r>
               <a:rPr sz="1300" b="1">
                 <a:solidFill>
-                  <a:srgbClr val="C15F3C"/>
+                  <a:srgbClr val="7B2D26"/>
                 </a:solidFill>
                 <a:latin typeface="Helvetica Neue"/>
               </a:rPr>
@@ -6346,7 +6346,7 @@
             <a:r>
               <a:rPr sz="1100" b="1" i="0">
                 <a:solidFill>
-                  <a:srgbClr val="C15F3C"/>
+                  <a:srgbClr val="7B2D26"/>
                 </a:solidFill>
                 <a:latin typeface="Helvetica Neue"/>
               </a:rPr>
@@ -6385,7 +6385,7 @@
             <a:r>
               <a:rPr sz="1300" b="1">
                 <a:solidFill>
-                  <a:srgbClr val="C15F3C"/>
+                  <a:srgbClr val="7B2D26"/>
                 </a:solidFill>
                 <a:latin typeface="Helvetica Neue"/>
               </a:rPr>
@@ -6410,7 +6410,7 @@
             <a:r>
               <a:rPr sz="1300" b="1">
                 <a:solidFill>
-                  <a:srgbClr val="C15F3C"/>
+                  <a:srgbClr val="7B2D26"/>
                 </a:solidFill>
                 <a:latin typeface="Helvetica Neue"/>
               </a:rPr>
@@ -6435,7 +6435,7 @@
             <a:r>
               <a:rPr sz="1300" b="1">
                 <a:solidFill>
-                  <a:srgbClr val="C15F3C"/>
+                  <a:srgbClr val="7B2D26"/>
                 </a:solidFill>
                 <a:latin typeface="Helvetica Neue"/>
               </a:rPr>
@@ -6460,7 +6460,7 @@
             <a:r>
               <a:rPr sz="1300" b="1">
                 <a:solidFill>
-                  <a:srgbClr val="C15F3C"/>
+                  <a:srgbClr val="7B2D26"/>
                 </a:solidFill>
                 <a:latin typeface="Helvetica Neue"/>
               </a:rPr>
@@ -6485,7 +6485,7 @@
             <a:r>
               <a:rPr sz="1300" b="1">
                 <a:solidFill>
-                  <a:srgbClr val="C15F3C"/>
+                  <a:srgbClr val="7B2D26"/>
                 </a:solidFill>
                 <a:latin typeface="Helvetica Neue"/>
               </a:rPr>
@@ -6510,7 +6510,7 @@
             <a:r>
               <a:rPr sz="1300" b="1">
                 <a:solidFill>
-                  <a:srgbClr val="C15F3C"/>
+                  <a:srgbClr val="7B2D26"/>
                 </a:solidFill>
                 <a:latin typeface="Helvetica Neue"/>
               </a:rPr>
@@ -6639,7 +6639,7 @@
             <a:avLst/>
           </a:prstGeom>
           <a:solidFill>
-            <a:srgbClr val="C15F3C"/>
+            <a:srgbClr val="7B2D26"/>
           </a:solidFill>
           <a:ln>
             <a:noFill/>
@@ -6728,7 +6728,7 @@
             <a:r>
               <a:rPr sz="1100" b="1" i="0">
                 <a:solidFill>
-                  <a:srgbClr val="C15F3C"/>
+                  <a:srgbClr val="7B2D26"/>
                 </a:solidFill>
                 <a:latin typeface="Helvetica Neue"/>
               </a:rPr>
@@ -6763,7 +6763,7 @@
             <a:r>
               <a:rPr sz="3200" b="1" i="0">
                 <a:solidFill>
-                  <a:srgbClr val="C15F3C"/>
+                  <a:srgbClr val="7B2D26"/>
                 </a:solidFill>
                 <a:latin typeface="Georgia"/>
               </a:rPr>
@@ -6833,7 +6833,7 @@
             <a:r>
               <a:rPr sz="3200" b="1" i="0">
                 <a:solidFill>
-                  <a:srgbClr val="C15F3C"/>
+                  <a:srgbClr val="7B2D26"/>
                 </a:solidFill>
                 <a:latin typeface="Georgia"/>
               </a:rPr>
@@ -6903,7 +6903,7 @@
             <a:r>
               <a:rPr sz="3200" b="1" i="0">
                 <a:solidFill>
-                  <a:srgbClr val="C15F3C"/>
+                  <a:srgbClr val="7B2D26"/>
                 </a:solidFill>
                 <a:latin typeface="Georgia"/>
               </a:rPr>
@@ -6973,7 +6973,7 @@
             <a:r>
               <a:rPr sz="2000" b="0" i="1">
                 <a:solidFill>
-                  <a:srgbClr val="C15F3C"/>
+                  <a:srgbClr val="7B2D26"/>
                 </a:solidFill>
                 <a:latin typeface="Georgia"/>
               </a:rPr>
@@ -7163,7 +7163,7 @@
             <a:avLst/>
           </a:prstGeom>
           <a:solidFill>
-            <a:srgbClr val="C15F3C"/>
+            <a:srgbClr val="7B2D26"/>
           </a:solidFill>
           <a:ln>
             <a:noFill/>
@@ -7252,7 +7252,7 @@
             <a:r>
               <a:rPr sz="7200" b="1" i="0">
                 <a:solidFill>
-                  <a:srgbClr val="C15F3C"/>
+                  <a:srgbClr val="7B2D26"/>
                 </a:solidFill>
                 <a:latin typeface="Georgia"/>
               </a:rPr>
@@ -7477,7 +7477,7 @@
             <a:avLst/>
           </a:prstGeom>
           <a:solidFill>
-            <a:srgbClr val="C15F3C"/>
+            <a:srgbClr val="7B2D26"/>
           </a:solidFill>
           <a:ln>
             <a:noFill/>
@@ -7566,7 +7566,7 @@
             <a:r>
               <a:rPr sz="1100" b="1" i="0">
                 <a:solidFill>
-                  <a:srgbClr val="C15F3C"/>
+                  <a:srgbClr val="7B2D26"/>
                 </a:solidFill>
                 <a:latin typeface="Helvetica Neue"/>
               </a:rPr>
@@ -7605,7 +7605,7 @@
             <a:r>
               <a:rPr sz="1600" b="1">
                 <a:solidFill>
-                  <a:srgbClr val="C15F3C"/>
+                  <a:srgbClr val="7B2D26"/>
                 </a:solidFill>
                 <a:latin typeface="Helvetica Neue"/>
               </a:rPr>
@@ -7630,7 +7630,7 @@
             <a:r>
               <a:rPr sz="1600" b="1">
                 <a:solidFill>
-                  <a:srgbClr val="C15F3C"/>
+                  <a:srgbClr val="7B2D26"/>
                 </a:solidFill>
                 <a:latin typeface="Helvetica Neue"/>
               </a:rPr>
@@ -7655,7 +7655,7 @@
             <a:r>
               <a:rPr sz="1600" b="1">
                 <a:solidFill>
-                  <a:srgbClr val="C15F3C"/>
+                  <a:srgbClr val="7B2D26"/>
                 </a:solidFill>
                 <a:latin typeface="Helvetica Neue"/>
               </a:rPr>
@@ -7680,7 +7680,7 @@
             <a:r>
               <a:rPr sz="1600" b="1">
                 <a:solidFill>
-                  <a:srgbClr val="C15F3C"/>
+                  <a:srgbClr val="7B2D26"/>
                 </a:solidFill>
                 <a:latin typeface="Helvetica Neue"/>
               </a:rPr>
@@ -7705,7 +7705,7 @@
             <a:r>
               <a:rPr sz="1600" b="1">
                 <a:solidFill>
-                  <a:srgbClr val="C15F3C"/>
+                  <a:srgbClr val="7B2D26"/>
                 </a:solidFill>
                 <a:latin typeface="Helvetica Neue"/>
               </a:rPr>
@@ -7749,7 +7749,7 @@
             <a:r>
               <a:rPr sz="1100" b="1" i="0">
                 <a:solidFill>
-                  <a:srgbClr val="C15F3C"/>
+                  <a:srgbClr val="7B2D26"/>
                 </a:solidFill>
                 <a:latin typeface="Helvetica Neue"/>
               </a:rPr>
@@ -7939,7 +7939,7 @@
             <a:avLst/>
           </a:prstGeom>
           <a:solidFill>
-            <a:srgbClr val="C15F3C"/>
+            <a:srgbClr val="7B2D26"/>
           </a:solidFill>
           <a:ln>
             <a:noFill/>
@@ -8032,7 +8032,7 @@
             <a:r>
               <a:rPr sz="2000" b="1">
                 <a:solidFill>
-                  <a:srgbClr val="C15F3C"/>
+                  <a:srgbClr val="7B2D26"/>
                 </a:solidFill>
                 <a:latin typeface="Helvetica Neue"/>
               </a:rPr>
@@ -8057,7 +8057,7 @@
             <a:r>
               <a:rPr sz="2000" b="1">
                 <a:solidFill>
-                  <a:srgbClr val="C15F3C"/>
+                  <a:srgbClr val="7B2D26"/>
                 </a:solidFill>
                 <a:latin typeface="Helvetica Neue"/>
               </a:rPr>
@@ -8082,7 +8082,7 @@
             <a:r>
               <a:rPr sz="2000" b="1">
                 <a:solidFill>
-                  <a:srgbClr val="C15F3C"/>
+                  <a:srgbClr val="7B2D26"/>
                 </a:solidFill>
                 <a:latin typeface="Helvetica Neue"/>
               </a:rPr>
@@ -8126,7 +8126,7 @@
             <a:r>
               <a:rPr sz="1800" b="1" i="1">
                 <a:solidFill>
-                  <a:srgbClr val="C15F3C"/>
+                  <a:srgbClr val="7B2D26"/>
                 </a:solidFill>
                 <a:latin typeface="Georgia"/>
               </a:rPr>
@@ -8246,7 +8246,7 @@
             <a:avLst/>
           </a:prstGeom>
           <a:solidFill>
-            <a:srgbClr val="C15F3C"/>
+            <a:srgbClr val="7B2D26"/>
           </a:solidFill>
           <a:ln>
             <a:noFill/>
@@ -8335,7 +8335,7 @@
             <a:r>
               <a:rPr sz="1100" b="1" i="0">
                 <a:solidFill>
-                  <a:srgbClr val="C15F3C"/>
+                  <a:srgbClr val="7B2D26"/>
                 </a:solidFill>
                 <a:latin typeface="Helvetica Neue"/>
               </a:rPr>
@@ -8440,7 +8440,7 @@
             <a:r>
               <a:rPr sz="1100" b="1" i="0">
                 <a:solidFill>
-                  <a:srgbClr val="C15F3C"/>
+                  <a:srgbClr val="7B2D26"/>
                 </a:solidFill>
                 <a:latin typeface="Helvetica Neue"/>
               </a:rPr>
@@ -8545,7 +8545,7 @@
             <a:r>
               <a:rPr sz="1100" b="1" i="0">
                 <a:solidFill>
-                  <a:srgbClr val="C15F3C"/>
+                  <a:srgbClr val="7B2D26"/>
                 </a:solidFill>
                 <a:latin typeface="Helvetica Neue"/>
               </a:rPr>
@@ -8735,7 +8735,7 @@
             <a:avLst/>
           </a:prstGeom>
           <a:solidFill>
-            <a:srgbClr val="C15F3C"/>
+            <a:srgbClr val="7B2D26"/>
           </a:solidFill>
           <a:ln>
             <a:noFill/>
@@ -8828,7 +8828,7 @@
             <a:r>
               <a:rPr sz="1500" b="1">
                 <a:solidFill>
-                  <a:srgbClr val="C15F3C"/>
+                  <a:srgbClr val="7B2D26"/>
                 </a:solidFill>
                 <a:latin typeface="Helvetica Neue"/>
               </a:rPr>
@@ -8853,7 +8853,7 @@
             <a:r>
               <a:rPr sz="1500" b="1">
                 <a:solidFill>
-                  <a:srgbClr val="C15F3C"/>
+                  <a:srgbClr val="7B2D26"/>
                 </a:solidFill>
                 <a:latin typeface="Helvetica Neue"/>
               </a:rPr>
@@ -8878,7 +8878,7 @@
             <a:r>
               <a:rPr sz="1500" b="1">
                 <a:solidFill>
-                  <a:srgbClr val="C15F3C"/>
+                  <a:srgbClr val="7B2D26"/>
                 </a:solidFill>
                 <a:latin typeface="Helvetica Neue"/>
               </a:rPr>
@@ -8903,7 +8903,7 @@
             <a:r>
               <a:rPr sz="1500" b="1">
                 <a:solidFill>
-                  <a:srgbClr val="C15F3C"/>
+                  <a:srgbClr val="7B2D26"/>
                 </a:solidFill>
                 <a:latin typeface="Helvetica Neue"/>
               </a:rPr>
@@ -8928,7 +8928,7 @@
             <a:r>
               <a:rPr sz="1500" b="1">
                 <a:solidFill>
-                  <a:srgbClr val="C15F3C"/>
+                  <a:srgbClr val="7B2D26"/>
                 </a:solidFill>
                 <a:latin typeface="Helvetica Neue"/>
               </a:rPr>
@@ -8953,7 +8953,7 @@
             <a:r>
               <a:rPr sz="1500" b="1">
                 <a:solidFill>
-                  <a:srgbClr val="C15F3C"/>
+                  <a:srgbClr val="7B2D26"/>
                 </a:solidFill>
                 <a:latin typeface="Helvetica Neue"/>
               </a:rPr>
@@ -8997,7 +8997,7 @@
             <a:r>
               <a:rPr sz="1100" b="1" i="0">
                 <a:solidFill>
-                  <a:srgbClr val="C15F3C"/>
+                  <a:srgbClr val="7B2D26"/>
                 </a:solidFill>
                 <a:latin typeface="Helvetica Neue"/>
               </a:rPr>
@@ -9141,7 +9141,7 @@
             <a:avLst/>
           </a:prstGeom>
           <a:solidFill>
-            <a:srgbClr val="C15F3C"/>
+            <a:srgbClr val="7B2D26"/>
           </a:solidFill>
           <a:ln>
             <a:noFill/>
@@ -9230,7 +9230,7 @@
             <a:r>
               <a:rPr sz="2800" b="1" i="0">
                 <a:solidFill>
-                  <a:srgbClr val="C15F3C"/>
+                  <a:srgbClr val="7B2D26"/>
                 </a:solidFill>
                 <a:latin typeface="Georgia"/>
               </a:rPr>
@@ -9335,7 +9335,7 @@
             <a:r>
               <a:rPr sz="2800" b="1" i="0">
                 <a:solidFill>
-                  <a:srgbClr val="C15F3C"/>
+                  <a:srgbClr val="7B2D26"/>
                 </a:solidFill>
                 <a:latin typeface="Georgia"/>
               </a:rPr>
@@ -9440,7 +9440,7 @@
             <a:r>
               <a:rPr sz="2800" b="1" i="0">
                 <a:solidFill>
-                  <a:srgbClr val="C15F3C"/>
+                  <a:srgbClr val="7B2D26"/>
                 </a:solidFill>
                 <a:latin typeface="Georgia"/>
               </a:rPr>
@@ -9545,7 +9545,7 @@
             <a:r>
               <a:rPr sz="2800" b="1" i="0">
                 <a:solidFill>
-                  <a:srgbClr val="C15F3C"/>
+                  <a:srgbClr val="7B2D26"/>
                 </a:solidFill>
                 <a:latin typeface="Georgia"/>
               </a:rPr>
@@ -9650,7 +9650,7 @@
             <a:r>
               <a:rPr sz="1400" b="0" i="1">
                 <a:solidFill>
-                  <a:srgbClr val="C15F3C"/>
+                  <a:srgbClr val="7B2D26"/>
                 </a:solidFill>
                 <a:latin typeface="Georgia"/>
               </a:rPr>
@@ -9770,7 +9770,7 @@
             <a:avLst/>
           </a:prstGeom>
           <a:solidFill>
-            <a:srgbClr val="C15F3C"/>
+            <a:srgbClr val="7B2D26"/>
           </a:solidFill>
           <a:ln>
             <a:noFill/>
@@ -9883,7 +9883,7 @@
             <a:r>
               <a:rPr sz="1100" b="1" i="0">
                 <a:solidFill>
-                  <a:srgbClr val="C15F3C"/>
+                  <a:srgbClr val="7B2D26"/>
                 </a:solidFill>
                 <a:latin typeface="Helvetica Neue"/>
               </a:rPr>
@@ -10213,7 +10213,7 @@
             <a:avLst/>
           </a:prstGeom>
           <a:solidFill>
-            <a:srgbClr val="C15F3C"/>
+            <a:srgbClr val="7B2D26"/>
           </a:solidFill>
           <a:ln>
             <a:noFill/>
@@ -10326,7 +10326,7 @@
             <a:r>
               <a:rPr sz="1100" b="1" i="0">
                 <a:solidFill>
-                  <a:srgbClr val="C15F3C"/>
+                  <a:srgbClr val="7B2D26"/>
                 </a:solidFill>
                 <a:latin typeface="Helvetica Neue"/>
               </a:rPr>
@@ -10361,7 +10361,7 @@
             <a:r>
               <a:rPr sz="7200" b="1" i="0">
                 <a:solidFill>
-                  <a:srgbClr val="C15F3C"/>
+                  <a:srgbClr val="7B2D26"/>
                 </a:solidFill>
                 <a:latin typeface="Georgia"/>
               </a:rPr>

</xml_diff>

<commit_message>
Update presentation: refresh stale figures and add live model URL
- Replace stale fig_time_to_stress (slide 9) and fig_scenario_compare
  (slide 12) with current versions from figures/
- Add HF Space URL (https://jed08-parched.hf.space/) to slide 8
  (How To Read The Simulation) and slide 14 (Conclusion / Q&A)

Co-Authored-By: Claude Sonnet 4.6 <noreply@anthropic.com>
</commit_message>
<xml_diff>
--- a/presentation/PARCHED_final.pptx
+++ b/presentation/PARCHED_final.pptx
@@ -7122,6 +7122,39 @@
           </a:p>
         </p:txBody>
       </p:sp>
+      <p:sp>
+        <p:nvSpPr>
+          <p:cNvPr id="16" name="TextBox 15"/>
+          <p:cNvSpPr txBox="1"/>
+          <p:nvPr/>
+        </p:nvSpPr>
+        <p:spPr>
+          <a:xfrm>
+            <a:off x="228600" y="6126480"/>
+            <a:ext cx="5486400" cy="365760"/>
+          </a:xfrm>
+          <a:prstGeom prst="rect">
+            <a:avLst/>
+          </a:prstGeom>
+          <a:noFill/>
+        </p:spPr>
+        <p:txBody>
+          <a:bodyPr wrap="none">
+            <a:spAutoFit/>
+          </a:bodyPr>
+          <a:lstStyle/>
+          <a:p>
+            <a:r>
+              <a:rPr sz="1100" b="1">
+                <a:solidFill>
+                  <a:srgbClr val="58A6FF"/>
+                </a:solidFill>
+              </a:rPr>
+              <a:t>🌐  Live model → https://jed08-parched.hf.space/</a:t>
+            </a:r>
+          </a:p>
+        </p:txBody>
+      </p:sp>
     </p:spTree>
   </p:cSld>
   <p:clrMapOvr>
@@ -10168,6 +10201,39 @@
                 <a:latin typeface="Helvetica Neue"/>
               </a:rPr>
               <a:t>8 / 14</a:t>
+            </a:r>
+          </a:p>
+        </p:txBody>
+      </p:sp>
+      <p:sp>
+        <p:nvSpPr>
+          <p:cNvPr id="14" name="TextBox 13"/>
+          <p:cNvSpPr txBox="1"/>
+          <p:nvPr/>
+        </p:nvSpPr>
+        <p:spPr>
+          <a:xfrm>
+            <a:off x="228600" y="6126480"/>
+            <a:ext cx="5486400" cy="365760"/>
+          </a:xfrm>
+          <a:prstGeom prst="rect">
+            <a:avLst/>
+          </a:prstGeom>
+          <a:noFill/>
+        </p:spPr>
+        <p:txBody>
+          <a:bodyPr wrap="none">
+            <a:spAutoFit/>
+          </a:bodyPr>
+          <a:lstStyle/>
+          <a:p>
+            <a:r>
+              <a:rPr sz="1100" b="1">
+                <a:solidFill>
+                  <a:srgbClr val="58A6FF"/>
+                </a:solidFill>
+              </a:rPr>
+              <a:t>🌐  https://jed08-parched.hf.space/</a:t>
             </a:r>
           </a:p>
         </p:txBody>

</xml_diff>

<commit_message>
Update presentation and paper with population growth + DC restoration
- Fresh simulation screenshot (shows DC Restore % + Pop Growth %/yr sliders,
  population counter in agent status, DC expansion step, seasonal farm cycle)
- build_deck.py: updated slide 6 bullets (growing population, DC restoration),
  slide 3 (growing population note), slide 13 limitations, speaker notes
- Rebuilt PARCHED_final.pptx (14 slides)
- main.tex: abstract, ResidentialCommunity description (compound growth formula),
  DataCenterOperator description (restoration term + math), Limitations updated

Co-Authored-By: Claude Sonnet 4.6 <noreply@anthropic.com>
</commit_message>
<xml_diff>
--- a/presentation/PARCHED_final.pptx
+++ b/presentation/PARCHED_final.pptx
@@ -1215,7 +1215,7 @@
           <a:lstStyle/>
           <a:p>
             <a:r>
-              <a:t>Quick architectural tour. We have four data centers with heterogeneous capacity, so they do not all draw the same. Two farms, one rainfed and one irrigated, which gives us a non-DC consumer with very different demand seasonality. One hundred thousand residents, whose draw follows a temperature-modulated demand curve. A regulator that can issue caps but only sees the basin state with a configurable delay. And the basin itself, thirty billion liters of usable capacity with stochastic recharge from rainfall. One tick is one day, the model runs for ten years or until collapse, whichever comes first. The single most important mechanism is the cooling-stress positive feedback loop, which is what produces the nonlinear regime, and we will see it light up in the H2 result.</a:t>
+              <a:t>Quick architectural tour. We have four data centers with heterogeneous capacity that expand on a fixed nine-month schedule, regardless of basin state. Two farms with seasonal demand, one rainfed and one irrigated. One residential community that starts at one hundred thousand people and grows at a configurable annual rate, so its water need compounds over time just like a real city. A regulator that can issue caps but only sees the basin state with a stochastic delay. And we also model DC water restoration, where data centers return a fraction of their daily draw to the basin via funded recharge projects, modeling real-world water-positive pledges from operators like Microsoft and Google. One tick is one day, the model runs for ten years or until collapse. The single most important mechanism is the cooling-stress positive feedback loop, which produces the nonlinear cliff we will see in H2.</a:t>
             </a:r>
           </a:p>
         </p:txBody>
@@ -5896,7 +5896,7 @@
         <p:spPr>
           <a:xfrm>
             <a:off x="7800000" y="2000000"/>
-            <a:ext cx="4833333" cy="3567354"/>
+            <a:ext cx="4833333" cy="3568991"/>
           </a:xfrm>
           <a:prstGeom prst="rect">
             <a:avLst/>
@@ -5911,7 +5911,7 @@
         </p:nvSpPr>
         <p:spPr>
           <a:xfrm>
-            <a:off x="7800000" y="5647354"/>
+            <a:off x="7800000" y="5648991"/>
             <a:ext cx="4833333" cy="400000"/>
           </a:xfrm>
           <a:prstGeom prst="rect">
@@ -6215,7 +6215,7 @@
                 </a:solidFill>
                 <a:latin typeface="Helvetica Neue"/>
               </a:rPr>
-              <a:t>No climate-change drift</a:t>
+              <a:t>No climate-change drift in recharge mean</a:t>
             </a:r>
           </a:p>
           <a:p>
@@ -6290,7 +6290,7 @@
                 </a:solidFill>
                 <a:latin typeface="Helvetica Neue"/>
               </a:rPr>
-              <a:t>Demand is exogenous</a:t>
+              <a:t>DC demand is exogenous (compute growth not price-responsive)</a:t>
             </a:r>
           </a:p>
           <a:p>
@@ -6423,7 +6423,7 @@
                 </a:solidFill>
                 <a:latin typeface="Helvetica Neue"/>
               </a:rPr>
-              <a:t>Climate-change scenarios (drift in recharge)</a:t>
+              <a:t>Climate-change scenarios (drift in recharge mean)</a:t>
             </a:r>
           </a:p>
           <a:p>
@@ -6448,7 +6448,7 @@
                 </a:solidFill>
                 <a:latin typeface="Helvetica Neue"/>
               </a:rPr>
-              <a:t>Real permit-process modeling</a:t>
+              <a:t>Real permit-process modeling (political delay curves)</a:t>
             </a:r>
           </a:p>
           <a:p>
@@ -6498,7 +6498,7 @@
                 </a:solidFill>
                 <a:latin typeface="Helvetica Neue"/>
               </a:rPr>
-              <a:t>Endogenous demand response (price elasticity)</a:t>
+              <a:t>Endogenous DC demand response (price / water cost)</a:t>
             </a:r>
           </a:p>
           <a:p>
@@ -6523,7 +6523,7 @@
                 </a:solidFill>
                 <a:latin typeface="Helvetica Neue"/>
               </a:rPr>
-              <a:t>Calibrate to a real candidate basin</a:t>
+              <a:t>Calibrate to a real candidate basin (Pacific NW, Chile)</a:t>
             </a:r>
           </a:p>
         </p:txBody>
@@ -7122,39 +7122,6 @@
           </a:p>
         </p:txBody>
       </p:sp>
-      <p:sp>
-        <p:nvSpPr>
-          <p:cNvPr id="16" name="TextBox 15"/>
-          <p:cNvSpPr txBox="1"/>
-          <p:nvPr/>
-        </p:nvSpPr>
-        <p:spPr>
-          <a:xfrm>
-            <a:off x="228600" y="6126480"/>
-            <a:ext cx="5486400" cy="365760"/>
-          </a:xfrm>
-          <a:prstGeom prst="rect">
-            <a:avLst/>
-          </a:prstGeom>
-          <a:noFill/>
-        </p:spPr>
-        <p:txBody>
-          <a:bodyPr wrap="none">
-            <a:spAutoFit/>
-          </a:bodyPr>
-          <a:lstStyle/>
-          <a:p>
-            <a:r>
-              <a:rPr sz="1100" b="1">
-                <a:solidFill>
-                  <a:srgbClr val="58A6FF"/>
-                </a:solidFill>
-              </a:rPr>
-              <a:t>🌐  Live model → https://jed08-parched.hf.space/</a:t>
-            </a:r>
-          </a:p>
-        </p:txBody>
-      </p:sp>
     </p:spTree>
   </p:cSld>
   <p:clrMapOvr>
@@ -7701,7 +7668,7 @@
                 </a:solidFill>
                 <a:latin typeface="Helvetica Neue"/>
               </a:rPr>
-              <a:t>Residential demand (~100k people)</a:t>
+              <a:t>Residential demand (~100k people, growing each year)</a:t>
             </a:r>
           </a:p>
           <a:p>
@@ -8874,7 +8841,7 @@
                 </a:solidFill>
                 <a:latin typeface="Helvetica Neue"/>
               </a:rPr>
-              <a:t>4 data centers (heterogeneous capacity)</a:t>
+              <a:t>4 data centers (heterogeneous capacity, expand every ~9 months)</a:t>
             </a:r>
           </a:p>
           <a:p>
@@ -8899,7 +8866,7 @@
                 </a:solidFill>
                 <a:latin typeface="Helvetica Neue"/>
               </a:rPr>
-              <a:t>2 farms (rainfed and irrigated)</a:t>
+              <a:t>2 farms (rainfed and irrigated, seasonal demand)</a:t>
             </a:r>
           </a:p>
           <a:p>
@@ -8924,7 +8891,7 @@
                 </a:solidFill>
                 <a:latin typeface="Helvetica Neue"/>
               </a:rPr>
-              <a:t>100k residents (consumption from demand curve)</a:t>
+              <a:t>1 residential community (growing population, compound growth)</a:t>
             </a:r>
           </a:p>
           <a:p>
@@ -8949,7 +8916,7 @@
                 </a:solidFill>
                 <a:latin typeface="Helvetica Neue"/>
               </a:rPr>
-              <a:t>1 regulator (delayed observability)</a:t>
+              <a:t>1 regulator (delayed observability, 4 policy modes)</a:t>
             </a:r>
           </a:p>
           <a:p>
@@ -8974,7 +8941,7 @@
                 </a:solidFill>
                 <a:latin typeface="Helvetica Neue"/>
               </a:rPr>
-              <a:t>30 BL shared basin, with stochastic recharge</a:t>
+              <a:t>30 BL shared basin, stochastic recharge + nonlinear penalty</a:t>
             </a:r>
           </a:p>
           <a:p>
@@ -8999,7 +8966,7 @@
                 </a:solidFill>
                 <a:latin typeface="Helvetica Neue"/>
               </a:rPr>
-              <a:t>All interactions mediated through the basin</a:t>
+              <a:t>DC water restoration: configurable replenishment fraction</a:t>
             </a:r>
           </a:p>
         </p:txBody>
@@ -9034,7 +9001,7 @@
                 </a:solidFill>
                 <a:latin typeface="Helvetica Neue"/>
               </a:rPr>
-              <a:t>1 tick = 1 day   /   10-year horizon   /   stop on collapse</a:t>
+              <a:t>1 tick = 1 day   /   10-year horizon   /   stop on collapse   /   live at jed08-parched.hf.space</a:t>
             </a:r>
           </a:p>
         </p:txBody>
@@ -9055,8 +9022,8 @@
         </p:blipFill>
         <p:spPr>
           <a:xfrm>
-            <a:off x="6433333" y="2250759"/>
-            <a:ext cx="6200000" cy="3798481"/>
+            <a:off x="6433333" y="2279667"/>
+            <a:ext cx="6200000" cy="3740666"/>
           </a:xfrm>
           <a:prstGeom prst="rect">
             <a:avLst/>
@@ -10201,39 +10168,6 @@
                 <a:latin typeface="Helvetica Neue"/>
               </a:rPr>
               <a:t>8 / 14</a:t>
-            </a:r>
-          </a:p>
-        </p:txBody>
-      </p:sp>
-      <p:sp>
-        <p:nvSpPr>
-          <p:cNvPr id="14" name="TextBox 13"/>
-          <p:cNvSpPr txBox="1"/>
-          <p:nvPr/>
-        </p:nvSpPr>
-        <p:spPr>
-          <a:xfrm>
-            <a:off x="228600" y="6126480"/>
-            <a:ext cx="5486400" cy="365760"/>
-          </a:xfrm>
-          <a:prstGeom prst="rect">
-            <a:avLst/>
-          </a:prstGeom>
-          <a:noFill/>
-        </p:spPr>
-        <p:txBody>
-          <a:bodyPr wrap="none">
-            <a:spAutoFit/>
-          </a:bodyPr>
-          <a:lstStyle/>
-          <a:p>
-            <a:r>
-              <a:rPr sz="1100" b="1">
-                <a:solidFill>
-                  <a:srgbClr val="58A6FF"/>
-                </a:solidFill>
-              </a:rPr>
-              <a:t>🌐  https://jed08-parched.hf.space/</a:t>
             </a:r>
           </a:p>
         </p:txBody>

</xml_diff>

<commit_message>
Add slide 12: restoration threshold finding + update conclusion takeaways
Key finding: DC Restore >= 100% flips data centers from aquifer drains to
replenishers, sustaining even the unregulated scenario indefinitely.
References Microsoft and Google water-positive pledges as real-world parallel.

Co-Authored-By: Claude Sonnet 4.6 <noreply@anthropic.com>
</commit_message>
<xml_diff>
--- a/presentation/PARCHED_final.pptx
+++ b/presentation/PARCHED_final.pptx
@@ -19,6 +19,7 @@
     <p:sldId id="267" r:id="rId19"/>
     <p:sldId id="268" r:id="rId20"/>
     <p:sldId id="269" r:id="rId21"/>
+    <p:sldId id="270" r:id="rId22"/>
   </p:sldIdLst>
   <p:sldSz cx="13333333" cy="7500000" type="screen4x3"/>
   <p:notesSz cx="6858000" cy="9144000"/>
@@ -725,7 +726,7 @@
           <a:lstStyle/>
           <a:p>
             <a:r>
-              <a:t>Pulling back, four discussion points. First, self-reporting from individual operators cannot tell you what is happening to the basin. You need a shared, real-time view, basin-level visibility. Second, reactive policy calibrated to conventional thresholds, like thirty percent storage, is structurally equivalent to no policy. It just signs off on the collapse a little later. Third, staggered entry buys time but not safety. The long-run equilibrium is the same. Fourth, and this is the punchline, the nine-times acceleration we found in H2 means that by the time politicians and the press are paying attention, the system is already in the cliff. Real-world parallels are not hypothetical here, think Phoenix, The Dalles in Oregon, Santiago in Chile. Real basins also have climate drift and contamination, which our model does not capture, and those make the situation worse, not better.</a:t>
+              <a:t>This finding came out of running the model with the DC Restore parameter turned up. Here is the narrative. Without restoration our unregulated baseline collapses every single run, mean six years. Now we turn on restoration, which models the water-positive pledges that companies like Microsoft and Google have made publicly: Microsoft wants to be water-positive by 2030, meaning it replenishes more than it consumes. Google has committed to replenishing one hundred and twenty percent of its consumption. We added this mechanism to the model as a configurable fraction of daily draw that is returned to the basin each day. The result is striking. At a hundred percent restoration, the basin stabilizes even under the unregulated scenario. At a hundred and fifty percent, the basin fills to capacity and the net daily aquifer change is positive thirty six point eight megaliters per day. Four data centers running at full capacity, population grown to one hundred and thirty five thousand, zero agricultural complaints. The policy implication is that if restoration obligations are written into operating permits at or above the hundred percent threshold, the regulatory policy mode becomes secondary. The data center itself becomes a water infrastructure asset, not a liability.</a:t>
             </a:r>
           </a:p>
         </p:txBody>
@@ -795,7 +796,7 @@
           <a:lstStyle/>
           <a:p>
             <a:r>
-              <a:t>Limitations, briefly. Our parameters are synthetic, drawn from the literature and calibrated for internal consistency, but they are not validated against any single real basin. We do not model climate-change drift, which would make recharge less reliable over time. We treat the basin as a closed system with no inter-basin trade. The regulator, once it observes the basin, has perfect information. Demand is exogenous, meaning households and farms do not respond to prices. And our agricultural yield loss is binary in a way real crops are not. On the future-work side, the most interesting extensions are inter-basin trade, climate scenarios with drifting recharge, modeling the actual permit process with the political delays it implies, and a calibration exercise against a real candidate basin in the Pacific Northwest or in Latin America.</a:t>
+              <a:t>Pulling back, four discussion points. First, self-reporting from individual operators cannot tell you what is happening to the basin. You need a shared, real-time view, basin-level visibility. Second, reactive policy calibrated to conventional thresholds, like thirty percent storage, is structurally equivalent to no policy. It just signs off on the collapse a little later. Third, staggered entry buys time but not safety. The long-run equilibrium is the same. Fourth, and this is the punchline, the nine-times acceleration we found in H2 means that by the time politicians and the press are paying attention, the system is already in the cliff. Real-world parallels are not hypothetical here, think Phoenix, The Dalles in Oregon, Santiago in Chile. Real basins also have climate drift and contamination, which our model does not capture, and those make the situation worse, not better.</a:t>
             </a:r>
           </a:p>
         </p:txBody>
@@ -821,6 +822,76 @@
 </file>
 
 <file path=ppt/notesSlides/notesSlide14.xml><?xml version="1.0" encoding="utf-8"?>
+<p:notes xmlns:a="http://schemas.openxmlformats.org/drawingml/2006/main" xmlns:p="http://schemas.openxmlformats.org/presentationml/2006/main" xmlns:r="http://schemas.openxmlformats.org/officeDocument/2006/relationships">
+  <p:cSld>
+    <p:spTree>
+      <p:nvGrpSpPr>
+        <p:cNvPr id="1" name=""/>
+        <p:cNvGrpSpPr/>
+        <p:nvPr/>
+      </p:nvGrpSpPr>
+      <p:grpSpPr>
+        <a:xfrm>
+          <a:off x="0" y="0"/>
+          <a:ext cx="0" cy="0"/>
+          <a:chOff x="0" y="0"/>
+          <a:chExt cx="0" cy="0"/>
+        </a:xfrm>
+      </p:grpSpPr>
+      <p:sp>
+        <p:nvSpPr>
+          <p:cNvPr id="2" name="Slide Image Placeholder 1"/>
+          <p:cNvSpPr>
+            <a:spLocks noGrp="1"/>
+          </p:cNvSpPr>
+          <p:nvPr>
+            <p:ph type="sldImg" idx="2"/>
+          </p:nvPr>
+        </p:nvSpPr>
+        <p:spPr/>
+      </p:sp>
+      <p:sp>
+        <p:nvSpPr>
+          <p:cNvPr id="3" name="Notes Placeholder 2"/>
+          <p:cNvSpPr>
+            <a:spLocks noGrp="1"/>
+          </p:cNvSpPr>
+          <p:nvPr>
+            <p:ph type="body" idx="3" sz="quarter"/>
+          </p:nvPr>
+        </p:nvSpPr>
+        <p:spPr/>
+        <p:txBody>
+          <a:bodyPr/>
+          <a:lstStyle/>
+          <a:p>
+            <a:r>
+              <a:t>Limitations, briefly. Our parameters are synthetic, drawn from the literature and calibrated for internal consistency, but they are not validated against any single real basin. We do not model climate-change drift, which would make recharge less reliable over time. We treat the basin as a closed system with no inter-basin trade. The regulator, once it observes the basin, has perfect information. Demand is exogenous, meaning households and farms do not respond to prices. And our agricultural yield loss is binary in a way real crops are not. On the future-work side, the most interesting extensions are inter-basin trade, climate scenarios with drifting recharge, modeling the actual permit process with the political delays it implies, and a calibration exercise against a real candidate basin in the Pacific Northwest or in Latin America.</a:t>
+            </a:r>
+          </a:p>
+        </p:txBody>
+      </p:sp>
+      <p:sp>
+        <p:nvSpPr>
+          <p:cNvPr id="4" name="Slide Number Placeholder 3"/>
+          <p:cNvSpPr>
+            <a:spLocks noGrp="1"/>
+          </p:cNvSpPr>
+          <p:nvPr>
+            <p:ph type="sldNum" idx="5" sz="quarter"/>
+          </p:nvPr>
+        </p:nvSpPr>
+        <p:spPr/>
+      </p:sp>
+    </p:spTree>
+  </p:cSld>
+  <p:clrMapOvr>
+    <a:masterClrMapping/>
+  </p:clrMapOvr>
+</p:notes>
+</file>
+
+<file path=ppt/notesSlides/notesSlide15.xml><?xml version="1.0" encoding="utf-8"?>
 <p:notes xmlns:a="http://schemas.openxmlformats.org/drawingml/2006/main" xmlns:p="http://schemas.openxmlformats.org/presentationml/2006/main" xmlns:r="http://schemas.openxmlformats.org/officeDocument/2006/relationships">
   <p:cSld>
     <p:spTree>
@@ -4796,7 +4867,7 @@
                 </a:solidFill>
                 <a:latin typeface="Helvetica Neue"/>
               </a:rPr>
-              <a:t>1 / 14</a:t>
+              <a:t>1 / 15</a:t>
             </a:r>
           </a:p>
         </p:txBody>
@@ -5204,7 +5275,7 @@
                 </a:solidFill>
                 <a:latin typeface="Helvetica Neue"/>
               </a:rPr>
-              <a:t>10 / 14</a:t>
+              <a:t>10 / 15</a:t>
             </a:r>
           </a:p>
         </p:txBody>
@@ -5647,7 +5718,7 @@
                 </a:solidFill>
                 <a:latin typeface="Helvetica Neue"/>
               </a:rPr>
-              <a:t>11 / 14</a:t>
+              <a:t>11 / 15</a:t>
             </a:r>
           </a:p>
         </p:txBody>
@@ -5751,7 +5822,7 @@
                 </a:solidFill>
                 <a:latin typeface="Georgia"/>
               </a:rPr>
-              <a:t>Discussion: What The Model Says</a:t>
+              <a:t>Bonus Finding: The Restoration Threshold</a:t>
             </a:r>
           </a:p>
         </p:txBody>
@@ -5764,8 +5835,78 @@
         </p:nvSpPr>
         <p:spPr>
           <a:xfrm>
-            <a:off x="700000" y="1900000"/>
-            <a:ext cx="6700000" cy="4800000"/>
+            <a:off x="700000" y="1700000"/>
+            <a:ext cx="11933333" cy="350000"/>
+          </a:xfrm>
+          <a:prstGeom prst="rect">
+            <a:avLst/>
+          </a:prstGeom>
+          <a:noFill/>
+        </p:spPr>
+        <p:txBody>
+          <a:bodyPr wrap="square" lIns="0" rIns="0" tIns="0" bIns="0" anchor="t">
+            <a:spAutoFit/>
+          </a:bodyPr>
+          <a:lstStyle/>
+          <a:p>
+            <a:pPr algn="l"/>
+            <a:r>
+              <a:rPr sz="1100" b="1" i="0">
+                <a:solidFill>
+                  <a:srgbClr val="7B2D26"/>
+                </a:solidFill>
+                <a:latin typeface="Helvetica Neue"/>
+              </a:rPr>
+              <a:t>WHAT HAPPENS WHEN DATA CENTERS GIVE WATER BACK?</a:t>
+            </a:r>
+          </a:p>
+        </p:txBody>
+      </p:sp>
+      <p:sp>
+        <p:nvSpPr>
+          <p:cNvPr id="5" name="TextBox 4"/>
+          <p:cNvSpPr txBox="1"/>
+          <p:nvPr/>
+        </p:nvSpPr>
+        <p:spPr>
+          <a:xfrm>
+            <a:off x="700000" y="2150000"/>
+            <a:ext cx="5600000" cy="450000"/>
+          </a:xfrm>
+          <a:prstGeom prst="rect">
+            <a:avLst/>
+          </a:prstGeom>
+          <a:noFill/>
+        </p:spPr>
+        <p:txBody>
+          <a:bodyPr wrap="square" lIns="0" rIns="0" tIns="0" bIns="0" anchor="t">
+            <a:spAutoFit/>
+          </a:bodyPr>
+          <a:lstStyle/>
+          <a:p>
+            <a:pPr algn="l"/>
+            <a:r>
+              <a:rPr sz="1500" b="1" i="0">
+                <a:solidFill>
+                  <a:srgbClr val="1F1E1D"/>
+                </a:solidFill>
+                <a:latin typeface="Helvetica Neue"/>
+              </a:rPr>
+              <a:t>WITHOUT restoration (baseline):</a:t>
+            </a:r>
+          </a:p>
+        </p:txBody>
+      </p:sp>
+      <p:sp>
+        <p:nvSpPr>
+          <p:cNvPr id="6" name="TextBox 5"/>
+          <p:cNvSpPr txBox="1"/>
+          <p:nvPr/>
+        </p:nvSpPr>
+        <p:spPr>
+          <a:xfrm>
+            <a:off x="700000" y="2600000"/>
+            <a:ext cx="5600000" cy="1100000"/>
           </a:xfrm>
           <a:prstGeom prst="rect">
             <a:avLst/>
@@ -5780,11 +5921,11 @@
           <a:p>
             <a:pPr algn="l">
               <a:lnSpc>
-                <a:spcPct val="150000"/>
+                <a:spcPct val="140000"/>
               </a:lnSpc>
             </a:pPr>
             <a:r>
-              <a:rPr sz="1400" b="1">
+              <a:rPr sz="1300" b="1">
                 <a:solidFill>
                   <a:srgbClr val="7B2D26"/>
                 </a:solidFill>
@@ -5793,23 +5934,23 @@
               <a:t>·  </a:t>
             </a:r>
             <a:r>
-              <a:rPr sz="1400">
+              <a:rPr sz="1300">
                 <a:solidFill>
                   <a:srgbClr val="1F1E1D"/>
                 </a:solidFill>
                 <a:latin typeface="Helvetica Neue"/>
               </a:rPr>
-              <a:t>Self-reporting is insufficient. Basin-level visibility is essential.</a:t>
+              <a:t>Basin drains, collapses in ~6 years</a:t>
             </a:r>
           </a:p>
           <a:p>
             <a:pPr algn="l">
               <a:lnSpc>
-                <a:spcPct val="150000"/>
+                <a:spcPct val="140000"/>
               </a:lnSpc>
             </a:pPr>
             <a:r>
-              <a:rPr sz="1400" b="1">
+              <a:rPr sz="1300" b="1">
                 <a:solidFill>
                   <a:srgbClr val="7B2D26"/>
                 </a:solidFill>
@@ -5818,23 +5959,81 @@
               <a:t>·  </a:t>
             </a:r>
             <a:r>
-              <a:rPr sz="1400">
+              <a:rPr sz="1300">
                 <a:solidFill>
                   <a:srgbClr val="1F1E1D"/>
                 </a:solidFill>
                 <a:latin typeface="Helvetica Neue"/>
               </a:rPr>
-              <a:t>Reactive policy at conventional thresholds is structurally equivalent to no policy.</a:t>
-            </a:r>
-          </a:p>
+              <a:t>Every unregulated run fails (100%, n=50)</a:t>
+            </a:r>
+          </a:p>
+        </p:txBody>
+      </p:sp>
+      <p:sp>
+        <p:nvSpPr>
+          <p:cNvPr id="7" name="TextBox 6"/>
+          <p:cNvSpPr txBox="1"/>
+          <p:nvPr/>
+        </p:nvSpPr>
+        <p:spPr>
+          <a:xfrm>
+            <a:off x="700000" y="3900000"/>
+            <a:ext cx="5600000" cy="450000"/>
+          </a:xfrm>
+          <a:prstGeom prst="rect">
+            <a:avLst/>
+          </a:prstGeom>
+          <a:noFill/>
+        </p:spPr>
+        <p:txBody>
+          <a:bodyPr wrap="square" lIns="0" rIns="0" tIns="0" bIns="0" anchor="t">
+            <a:spAutoFit/>
+          </a:bodyPr>
+          <a:lstStyle/>
+          <a:p>
+            <a:pPr algn="l"/>
+            <a:r>
+              <a:rPr sz="1500" b="1" i="0">
+                <a:solidFill>
+                  <a:srgbClr val="7B2D26"/>
+                </a:solidFill>
+                <a:latin typeface="Helvetica Neue"/>
+              </a:rPr>
+              <a:t>WITH restoration (DC Restore % &gt;= 100%):</a:t>
+            </a:r>
+          </a:p>
+        </p:txBody>
+      </p:sp>
+      <p:sp>
+        <p:nvSpPr>
+          <p:cNvPr id="8" name="TextBox 7"/>
+          <p:cNvSpPr txBox="1"/>
+          <p:nvPr/>
+        </p:nvSpPr>
+        <p:spPr>
+          <a:xfrm>
+            <a:off x="700000" y="4350000"/>
+            <a:ext cx="5600000" cy="1800000"/>
+          </a:xfrm>
+          <a:prstGeom prst="rect">
+            <a:avLst/>
+          </a:prstGeom>
+          <a:noFill/>
+        </p:spPr>
+        <p:txBody>
+          <a:bodyPr wrap="square" lIns="0" rIns="0" tIns="0" bIns="0" anchor="t">
+            <a:spAutoFit/>
+          </a:bodyPr>
+          <a:lstStyle/>
           <a:p>
             <a:pPr algn="l">
               <a:lnSpc>
-                <a:spcPct val="150000"/>
+                <a:spcPct val="140000"/>
               </a:lnSpc>
             </a:pPr>
             <a:r>
-              <a:rPr sz="1400" b="1">
+              <a:rPr sz="1300" b="1">
                 <a:solidFill>
                   <a:srgbClr val="7B2D26"/>
                 </a:solidFill>
@@ -5843,23 +6042,23 @@
               <a:t>·  </a:t>
             </a:r>
             <a:r>
-              <a:rPr sz="1400">
+              <a:rPr sz="1300">
                 <a:solidFill>
                   <a:srgbClr val="1F1E1D"/>
                 </a:solidFill>
                 <a:latin typeface="Helvetica Neue"/>
               </a:rPr>
-              <a:t>Staggered entry buys time, not safety. Long-run equilibrium is unchanged.</a:t>
+              <a:t>Basin climbs to 100% and holds -- even in Unregulated</a:t>
             </a:r>
           </a:p>
           <a:p>
             <a:pPr algn="l">
               <a:lnSpc>
-                <a:spcPct val="150000"/>
+                <a:spcPct val="140000"/>
               </a:lnSpc>
             </a:pPr>
             <a:r>
-              <a:rPr sz="1400" b="1">
+              <a:rPr sz="1300" b="1">
                 <a:solidFill>
                   <a:srgbClr val="7B2D26"/>
                 </a:solidFill>
@@ -5868,79 +6067,320 @@
               <a:t>·  </a:t>
             </a:r>
             <a:r>
-              <a:rPr sz="1400">
+              <a:rPr sz="1300">
                 <a:solidFill>
                   <a:srgbClr val="1F1E1D"/>
                 </a:solidFill>
                 <a:latin typeface="Helvetica Neue"/>
               </a:rPr>
-              <a:t>A 9x acceleration means by the time politicians notice, it is already too late.</a:t>
-            </a:r>
-          </a:p>
-        </p:txBody>
-      </p:sp>
-      <p:pic>
-        <p:nvPicPr>
-          <p:cNvPr id="5" name="Picture 4" descr="fig_scenario_compare.png"/>
-          <p:cNvPicPr>
-            <a:picLocks noChangeAspect="1"/>
-          </p:cNvPicPr>
-          <p:nvPr/>
-        </p:nvPicPr>
-        <p:blipFill>
-          <a:blip r:embed="rId2"/>
-          <a:stretch>
-            <a:fillRect/>
-          </a:stretch>
-        </p:blipFill>
-        <p:spPr>
-          <a:xfrm>
-            <a:off x="7800000" y="2000000"/>
-            <a:ext cx="4833333" cy="3568991"/>
-          </a:xfrm>
-          <a:prstGeom prst="rect">
-            <a:avLst/>
-          </a:prstGeom>
-        </p:spPr>
-      </p:pic>
-      <p:sp>
-        <p:nvSpPr>
-          <p:cNvPr id="6" name="TextBox 5"/>
-          <p:cNvSpPr txBox="1"/>
-          <p:nvPr/>
-        </p:nvSpPr>
-        <p:spPr>
-          <a:xfrm>
-            <a:off x="7800000" y="5648991"/>
-            <a:ext cx="4833333" cy="400000"/>
-          </a:xfrm>
-          <a:prstGeom prst="rect">
-            <a:avLst/>
-          </a:prstGeom>
-          <a:noFill/>
-        </p:spPr>
-        <p:txBody>
-          <a:bodyPr wrap="square" lIns="0" rIns="0" tIns="0" bIns="0" anchor="t">
-            <a:spAutoFit/>
-          </a:bodyPr>
-          <a:lstStyle/>
-          <a:p>
-            <a:pPr algn="ctr"/>
-            <a:r>
-              <a:rPr sz="1000" b="0" i="0">
+              <a:t>Net aquifer gain: +36.8 ML/day at 150% restore</a:t>
+            </a:r>
+          </a:p>
+          <a:p>
+            <a:pPr algn="l">
+              <a:lnSpc>
+                <a:spcPct val="140000"/>
+              </a:lnSpc>
+            </a:pPr>
+            <a:r>
+              <a:rPr sz="1300" b="1">
+                <a:solidFill>
+                  <a:srgbClr val="7B2D26"/>
+                </a:solidFill>
+                <a:latin typeface="Helvetica Neue"/>
+              </a:rPr>
+              <a:t>·  </a:t>
+            </a:r>
+            <a:r>
+              <a:rPr sz="1300">
+                <a:solidFill>
+                  <a:srgbClr val="1F1E1D"/>
+                </a:solidFill>
+                <a:latin typeface="Helvetica Neue"/>
+              </a:rPr>
+              <a:t>4 DCs running full capacity (47.7 ML total), zero complaints</a:t>
+            </a:r>
+          </a:p>
+          <a:p>
+            <a:pPr algn="l">
+              <a:lnSpc>
+                <a:spcPct val="140000"/>
+              </a:lnSpc>
+            </a:pPr>
+            <a:r>
+              <a:rPr sz="1300" b="1">
+                <a:solidFill>
+                  <a:srgbClr val="7B2D26"/>
+                </a:solidFill>
+                <a:latin typeface="Helvetica Neue"/>
+              </a:rPr>
+              <a:t>·  </a:t>
+            </a:r>
+            <a:r>
+              <a:rPr sz="1300">
+                <a:solidFill>
+                  <a:srgbClr val="1F1E1D"/>
+                </a:solidFill>
+                <a:latin typeface="Helvetica Neue"/>
+              </a:rPr>
+              <a:t>Population grew to 135,000 -- still fully sustained</a:t>
+            </a:r>
+          </a:p>
+        </p:txBody>
+      </p:sp>
+      <p:sp>
+        <p:nvSpPr>
+          <p:cNvPr id="9" name="TextBox 8"/>
+          <p:cNvSpPr txBox="1"/>
+          <p:nvPr/>
+        </p:nvSpPr>
+        <p:spPr>
+          <a:xfrm>
+            <a:off x="6700000" y="1700000"/>
+            <a:ext cx="6000000" cy="400000"/>
+          </a:xfrm>
+          <a:prstGeom prst="rect">
+            <a:avLst/>
+          </a:prstGeom>
+          <a:noFill/>
+        </p:spPr>
+        <p:txBody>
+          <a:bodyPr wrap="square" lIns="0" rIns="0" tIns="0" bIns="0" anchor="t">
+            <a:spAutoFit/>
+          </a:bodyPr>
+          <a:lstStyle/>
+          <a:p>
+            <a:pPr algn="l"/>
+            <a:r>
+              <a:rPr sz="1100" b="1" i="0">
+                <a:solidFill>
+                  <a:srgbClr val="7B2D26"/>
+                </a:solidFill>
+                <a:latin typeface="Helvetica Neue"/>
+              </a:rPr>
+              <a:t>THE THRESHOLD</a:t>
+            </a:r>
+          </a:p>
+        </p:txBody>
+      </p:sp>
+      <p:sp>
+        <p:nvSpPr>
+          <p:cNvPr id="10" name="TextBox 9"/>
+          <p:cNvSpPr txBox="1"/>
+          <p:nvPr/>
+        </p:nvSpPr>
+        <p:spPr>
+          <a:xfrm>
+            <a:off x="6700000" y="2100000"/>
+            <a:ext cx="6000000" cy="1400000"/>
+          </a:xfrm>
+          <a:prstGeom prst="rect">
+            <a:avLst/>
+          </a:prstGeom>
+          <a:noFill/>
+        </p:spPr>
+        <p:txBody>
+          <a:bodyPr wrap="square" lIns="0" rIns="0" tIns="0" bIns="0" anchor="t">
+            <a:spAutoFit/>
+          </a:bodyPr>
+          <a:lstStyle/>
+          <a:p>
+            <a:pPr algn="l"/>
+            <a:r>
+              <a:rPr sz="8000" b="1" i="0">
+                <a:solidFill>
+                  <a:srgbClr val="7B2D26"/>
+                </a:solidFill>
+                <a:latin typeface="Georgia"/>
+              </a:rPr>
+              <a:t>~100%</a:t>
+            </a:r>
+          </a:p>
+        </p:txBody>
+      </p:sp>
+      <p:sp>
+        <p:nvSpPr>
+          <p:cNvPr id="11" name="TextBox 10"/>
+          <p:cNvSpPr txBox="1"/>
+          <p:nvPr/>
+        </p:nvSpPr>
+        <p:spPr>
+          <a:xfrm>
+            <a:off x="6700000" y="3500000"/>
+            <a:ext cx="6000000" cy="700000"/>
+          </a:xfrm>
+          <a:prstGeom prst="rect">
+            <a:avLst/>
+          </a:prstGeom>
+          <a:noFill/>
+        </p:spPr>
+        <p:txBody>
+          <a:bodyPr wrap="square" lIns="0" rIns="0" tIns="0" bIns="0" anchor="t">
+            <a:spAutoFit/>
+          </a:bodyPr>
+          <a:lstStyle/>
+          <a:p>
+            <a:pPr algn="l"/>
+            <a:r>
+              <a:rPr sz="1600" b="0" i="1">
+                <a:solidFill>
+                  <a:srgbClr val="1F1E1D"/>
+                </a:solidFill>
+                <a:latin typeface="Georgia"/>
+              </a:rPr>
+              <a:t>restoration rate flips DCs from</a:t>
+            </a:r>
+          </a:p>
+          <a:p>
+            <a:pPr algn="l"/>
+            <a:r>
+              <a:rPr sz="1600" b="0" i="1">
+                <a:solidFill>
+                  <a:srgbClr val="1F1E1D"/>
+                </a:solidFill>
+                <a:latin typeface="Georgia"/>
+              </a:rPr>
+              <a:t>aquifer drains to replenishers.</a:t>
+            </a:r>
+          </a:p>
+        </p:txBody>
+      </p:sp>
+      <p:sp>
+        <p:nvSpPr>
+          <p:cNvPr id="12" name="TextBox 11"/>
+          <p:cNvSpPr txBox="1"/>
+          <p:nvPr/>
+        </p:nvSpPr>
+        <p:spPr>
+          <a:xfrm>
+            <a:off x="6700000" y="4400000"/>
+            <a:ext cx="6000000" cy="400000"/>
+          </a:xfrm>
+          <a:prstGeom prst="rect">
+            <a:avLst/>
+          </a:prstGeom>
+          <a:noFill/>
+        </p:spPr>
+        <p:txBody>
+          <a:bodyPr wrap="square" lIns="0" rIns="0" tIns="0" bIns="0" anchor="t">
+            <a:spAutoFit/>
+          </a:bodyPr>
+          <a:lstStyle/>
+          <a:p>
+            <a:pPr algn="l"/>
+            <a:r>
+              <a:rPr sz="1100" b="1" i="0">
+                <a:solidFill>
+                  <a:srgbClr val="7B2D26"/>
+                </a:solidFill>
+                <a:latin typeface="Helvetica Neue"/>
+              </a:rPr>
+              <a:t>REAL-WORLD PARALLEL</a:t>
+            </a:r>
+          </a:p>
+        </p:txBody>
+      </p:sp>
+      <p:sp>
+        <p:nvSpPr>
+          <p:cNvPr id="13" name="TextBox 12"/>
+          <p:cNvSpPr txBox="1"/>
+          <p:nvPr/>
+        </p:nvSpPr>
+        <p:spPr>
+          <a:xfrm>
+            <a:off x="6700000" y="4850000"/>
+            <a:ext cx="6000000" cy="1600000"/>
+          </a:xfrm>
+          <a:prstGeom prst="rect">
+            <a:avLst/>
+          </a:prstGeom>
+          <a:noFill/>
+        </p:spPr>
+        <p:txBody>
+          <a:bodyPr wrap="square" lIns="0" rIns="0" tIns="0" bIns="0" anchor="t">
+            <a:spAutoFit/>
+          </a:bodyPr>
+          <a:lstStyle/>
+          <a:p>
+            <a:pPr algn="l">
+              <a:lnSpc>
+                <a:spcPct val="135000"/>
+              </a:lnSpc>
+            </a:pPr>
+            <a:r>
+              <a:rPr sz="1200" b="1">
+                <a:solidFill>
+                  <a:srgbClr val="7B2D26"/>
+                </a:solidFill>
+                <a:latin typeface="Helvetica Neue"/>
+              </a:rPr>
+              <a:t>·  </a:t>
+            </a:r>
+            <a:r>
+              <a:rPr sz="1200">
                 <a:solidFill>
                   <a:srgbClr val="605E5B"/>
                 </a:solidFill>
                 <a:latin typeface="Helvetica Neue"/>
               </a:rPr>
-              <a:t>Scenario comparison (A / B / C / D)</a:t>
-            </a:r>
-          </a:p>
-        </p:txBody>
-      </p:sp>
-      <p:sp>
-        <p:nvSpPr>
-          <p:cNvPr id="7" name="TextBox 6"/>
+              <a:t>Microsoft: water-positive pledge by 2030 (replenish &gt;100%)</a:t>
+            </a:r>
+          </a:p>
+          <a:p>
+            <a:pPr algn="l">
+              <a:lnSpc>
+                <a:spcPct val="135000"/>
+              </a:lnSpc>
+            </a:pPr>
+            <a:r>
+              <a:rPr sz="1200" b="1">
+                <a:solidFill>
+                  <a:srgbClr val="7B2D26"/>
+                </a:solidFill>
+                <a:latin typeface="Helvetica Neue"/>
+              </a:rPr>
+              <a:t>·  </a:t>
+            </a:r>
+            <a:r>
+              <a:rPr sz="1200">
+                <a:solidFill>
+                  <a:srgbClr val="605E5B"/>
+                </a:solidFill>
+                <a:latin typeface="Helvetica Neue"/>
+              </a:rPr>
+              <a:t>Google: replenish 120% of water consumed</a:t>
+            </a:r>
+          </a:p>
+          <a:p>
+            <a:pPr algn="l">
+              <a:lnSpc>
+                <a:spcPct val="135000"/>
+              </a:lnSpc>
+            </a:pPr>
+            <a:r>
+              <a:rPr sz="1200" b="1">
+                <a:solidFill>
+                  <a:srgbClr val="7B2D26"/>
+                </a:solidFill>
+                <a:latin typeface="Helvetica Neue"/>
+              </a:rPr>
+              <a:t>·  </a:t>
+            </a:r>
+            <a:r>
+              <a:rPr sz="1200">
+                <a:solidFill>
+                  <a:srgbClr val="605E5B"/>
+                </a:solidFill>
+                <a:latin typeface="Helvetica Neue"/>
+              </a:rPr>
+              <a:t>Our model quantifies the basin-level effect of that pledge</a:t>
+            </a:r>
+          </a:p>
+        </p:txBody>
+      </p:sp>
+      <p:sp>
+        <p:nvSpPr>
+          <p:cNvPr id="14" name="TextBox 13"/>
           <p:cNvSpPr txBox="1"/>
           <p:nvPr/>
         </p:nvSpPr>
@@ -5975,7 +6415,7 @@
       </p:sp>
       <p:sp>
         <p:nvSpPr>
-          <p:cNvPr id="8" name="TextBox 7"/>
+          <p:cNvPr id="15" name="TextBox 14"/>
           <p:cNvSpPr txBox="1"/>
           <p:nvPr/>
         </p:nvSpPr>
@@ -6003,7 +6443,7 @@
                 </a:solidFill>
                 <a:latin typeface="Helvetica Neue"/>
               </a:rPr>
-              <a:t>12 / 14</a:t>
+              <a:t>12 / 15</a:t>
             </a:r>
           </a:p>
         </p:txBody>
@@ -6107,7 +6547,7 @@
                 </a:solidFill>
                 <a:latin typeface="Georgia"/>
               </a:rPr>
-              <a:t>Limitations and Future Work</a:t>
+              <a:t>Discussion: What The Model Says</a:t>
             </a:r>
           </a:p>
         </p:txBody>
@@ -6120,43 +6560,8 @@
         </p:nvSpPr>
         <p:spPr>
           <a:xfrm>
-            <a:off x="700000" y="1800000"/>
-            <a:ext cx="5900000" cy="400000"/>
-          </a:xfrm>
-          <a:prstGeom prst="rect">
-            <a:avLst/>
-          </a:prstGeom>
-          <a:noFill/>
-        </p:spPr>
-        <p:txBody>
-          <a:bodyPr wrap="square" lIns="0" rIns="0" tIns="0" bIns="0" anchor="t">
-            <a:spAutoFit/>
-          </a:bodyPr>
-          <a:lstStyle/>
-          <a:p>
-            <a:pPr algn="l"/>
-            <a:r>
-              <a:rPr sz="1100" b="1" i="0">
-                <a:solidFill>
-                  <a:srgbClr val="7B2D26"/>
-                </a:solidFill>
-                <a:latin typeface="Helvetica Neue"/>
-              </a:rPr>
-              <a:t>LIMITATIONS</a:t>
-            </a:r>
-          </a:p>
-        </p:txBody>
-      </p:sp>
-      <p:sp>
-        <p:nvSpPr>
-          <p:cNvPr id="5" name="TextBox 4"/>
-          <p:cNvSpPr txBox="1"/>
-          <p:nvPr/>
-        </p:nvSpPr>
-        <p:spPr>
-          <a:xfrm>
-            <a:off x="700000" y="2250000"/>
-            <a:ext cx="5900000" cy="4500000"/>
+            <a:off x="700000" y="1900000"/>
+            <a:ext cx="6700000" cy="4800000"/>
           </a:xfrm>
           <a:prstGeom prst="rect">
             <a:avLst/>
@@ -6171,11 +6576,11 @@
           <a:p>
             <a:pPr algn="l">
               <a:lnSpc>
-                <a:spcPct val="140000"/>
+                <a:spcPct val="150000"/>
               </a:lnSpc>
             </a:pPr>
             <a:r>
-              <a:rPr sz="1300" b="1">
+              <a:rPr sz="1400" b="1">
                 <a:solidFill>
                   <a:srgbClr val="7B2D26"/>
                 </a:solidFill>
@@ -6184,23 +6589,23 @@
               <a:t>·  </a:t>
             </a:r>
             <a:r>
-              <a:rPr sz="1300">
+              <a:rPr sz="1400">
                 <a:solidFill>
                   <a:srgbClr val="1F1E1D"/>
                 </a:solidFill>
                 <a:latin typeface="Helvetica Neue"/>
               </a:rPr>
-              <a:t>Synthetic parameters (calibrated, not validated against a specific basin)</a:t>
+              <a:t>Self-reporting is insufficient. Basin-level visibility is essential.</a:t>
             </a:r>
           </a:p>
           <a:p>
             <a:pPr algn="l">
               <a:lnSpc>
-                <a:spcPct val="140000"/>
+                <a:spcPct val="150000"/>
               </a:lnSpc>
             </a:pPr>
             <a:r>
-              <a:rPr sz="1300" b="1">
+              <a:rPr sz="1400" b="1">
                 <a:solidFill>
                   <a:srgbClr val="7B2D26"/>
                 </a:solidFill>
@@ -6209,23 +6614,23 @@
               <a:t>·  </a:t>
             </a:r>
             <a:r>
-              <a:rPr sz="1300">
+              <a:rPr sz="1400">
                 <a:solidFill>
                   <a:srgbClr val="1F1E1D"/>
                 </a:solidFill>
                 <a:latin typeface="Helvetica Neue"/>
               </a:rPr>
-              <a:t>No climate-change drift in recharge mean</a:t>
+              <a:t>Reactive policy at conventional thresholds is structurally equivalent to no policy.</a:t>
             </a:r>
           </a:p>
           <a:p>
             <a:pPr algn="l">
               <a:lnSpc>
-                <a:spcPct val="140000"/>
+                <a:spcPct val="150000"/>
               </a:lnSpc>
             </a:pPr>
             <a:r>
-              <a:rPr sz="1300" b="1">
+              <a:rPr sz="1400" b="1">
                 <a:solidFill>
                   <a:srgbClr val="7B2D26"/>
                 </a:solidFill>
@@ -6234,23 +6639,23 @@
               <a:t>·  </a:t>
             </a:r>
             <a:r>
-              <a:rPr sz="1300">
+              <a:rPr sz="1400">
                 <a:solidFill>
                   <a:srgbClr val="1F1E1D"/>
                 </a:solidFill>
                 <a:latin typeface="Helvetica Neue"/>
               </a:rPr>
-              <a:t>Single basin, no inter-basin trade</a:t>
+              <a:t>Staggered entry buys time, not safety. Long-run equilibrium is unchanged.</a:t>
             </a:r>
           </a:p>
           <a:p>
             <a:pPr algn="l">
               <a:lnSpc>
-                <a:spcPct val="140000"/>
+                <a:spcPct val="150000"/>
               </a:lnSpc>
             </a:pPr>
             <a:r>
-              <a:rPr sz="1300" b="1">
+              <a:rPr sz="1400" b="1">
                 <a:solidFill>
                   <a:srgbClr val="7B2D26"/>
                 </a:solidFill>
@@ -6259,23 +6664,23 @@
               <a:t>·  </a:t>
             </a:r>
             <a:r>
-              <a:rPr sz="1300">
+              <a:rPr sz="1400">
                 <a:solidFill>
                   <a:srgbClr val="1F1E1D"/>
                 </a:solidFill>
                 <a:latin typeface="Helvetica Neue"/>
               </a:rPr>
-              <a:t>Regulator has perfect observability after delay</a:t>
+              <a:t>A 9x acceleration means by the time politicians notice, it is already too late.</a:t>
             </a:r>
           </a:p>
           <a:p>
             <a:pPr algn="l">
               <a:lnSpc>
-                <a:spcPct val="140000"/>
+                <a:spcPct val="150000"/>
               </a:lnSpc>
             </a:pPr>
             <a:r>
-              <a:rPr sz="1300" b="1">
+              <a:rPr sz="1400" b="1">
                 <a:solidFill>
                   <a:srgbClr val="7B2D26"/>
                 </a:solidFill>
@@ -6284,42 +6689,41 @@
               <a:t>·  </a:t>
             </a:r>
             <a:r>
-              <a:rPr sz="1300">
+              <a:rPr sz="1400">
                 <a:solidFill>
                   <a:srgbClr val="1F1E1D"/>
                 </a:solidFill>
                 <a:latin typeface="Helvetica Neue"/>
               </a:rPr>
-              <a:t>DC demand is exogenous (compute growth not price-responsive)</a:t>
-            </a:r>
-          </a:p>
-          <a:p>
-            <a:pPr algn="l">
-              <a:lnSpc>
-                <a:spcPct val="140000"/>
-              </a:lnSpc>
-            </a:pPr>
-            <a:r>
-              <a:rPr sz="1300" b="1">
-                <a:solidFill>
-                  <a:srgbClr val="7B2D26"/>
-                </a:solidFill>
-                <a:latin typeface="Helvetica Neue"/>
-              </a:rPr>
-              <a:t>·  </a:t>
-            </a:r>
-            <a:r>
-              <a:rPr sz="1300">
-                <a:solidFill>
-                  <a:srgbClr val="1F1E1D"/>
-                </a:solidFill>
-                <a:latin typeface="Helvetica Neue"/>
-              </a:rPr>
-              <a:t>Ag yield loss simplified: below threshold = dead</a:t>
-            </a:r>
-          </a:p>
-        </p:txBody>
-      </p:sp>
+              <a:t>Restoration obligations &gt;= 100% can flip a data center from threat to asset.</a:t>
+            </a:r>
+          </a:p>
+        </p:txBody>
+      </p:sp>
+      <p:pic>
+        <p:nvPicPr>
+          <p:cNvPr id="5" name="Picture 4" descr="fig_scenario_compare.png"/>
+          <p:cNvPicPr>
+            <a:picLocks noChangeAspect="1"/>
+          </p:cNvPicPr>
+          <p:nvPr/>
+        </p:nvPicPr>
+        <p:blipFill>
+          <a:blip r:embed="rId2"/>
+          <a:stretch>
+            <a:fillRect/>
+          </a:stretch>
+        </p:blipFill>
+        <p:spPr>
+          <a:xfrm>
+            <a:off x="7800000" y="2000000"/>
+            <a:ext cx="4833333" cy="3568991"/>
+          </a:xfrm>
+          <a:prstGeom prst="rect">
+            <a:avLst/>
+          </a:prstGeom>
+        </p:spPr>
+      </p:pic>
       <p:sp>
         <p:nvSpPr>
           <p:cNvPr id="6" name="TextBox 5"/>
@@ -6328,29 +6732,29 @@
         </p:nvSpPr>
         <p:spPr>
           <a:xfrm>
-            <a:off x="7100000" y="1800000"/>
-            <a:ext cx="5700000" cy="400000"/>
-          </a:xfrm>
-          <a:prstGeom prst="rect">
-            <a:avLst/>
-          </a:prstGeom>
-          <a:noFill/>
-        </p:spPr>
-        <p:txBody>
-          <a:bodyPr wrap="square" lIns="0" rIns="0" tIns="0" bIns="0" anchor="t">
-            <a:spAutoFit/>
-          </a:bodyPr>
-          <a:lstStyle/>
-          <a:p>
-            <a:pPr algn="l"/>
-            <a:r>
-              <a:rPr sz="1100" b="1" i="0">
-                <a:solidFill>
-                  <a:srgbClr val="7B2D26"/>
-                </a:solidFill>
-                <a:latin typeface="Helvetica Neue"/>
-              </a:rPr>
-              <a:t>FUTURE WORK</a:t>
+            <a:off x="7800000" y="5648991"/>
+            <a:ext cx="4833333" cy="400000"/>
+          </a:xfrm>
+          <a:prstGeom prst="rect">
+            <a:avLst/>
+          </a:prstGeom>
+          <a:noFill/>
+        </p:spPr>
+        <p:txBody>
+          <a:bodyPr wrap="square" lIns="0" rIns="0" tIns="0" bIns="0" anchor="t">
+            <a:spAutoFit/>
+          </a:bodyPr>
+          <a:lstStyle/>
+          <a:p>
+            <a:pPr algn="ctr"/>
+            <a:r>
+              <a:rPr sz="1000" b="0" i="0">
+                <a:solidFill>
+                  <a:srgbClr val="605E5B"/>
+                </a:solidFill>
+                <a:latin typeface="Helvetica Neue"/>
+              </a:rPr>
+              <a:t>Scenario comparison (A / B / C / D)</a:t>
             </a:r>
           </a:p>
         </p:txBody>
@@ -6358,179 +6762,6 @@
       <p:sp>
         <p:nvSpPr>
           <p:cNvPr id="7" name="TextBox 6"/>
-          <p:cNvSpPr txBox="1"/>
-          <p:nvPr/>
-        </p:nvSpPr>
-        <p:spPr>
-          <a:xfrm>
-            <a:off x="7100000" y="2250000"/>
-            <a:ext cx="5700000" cy="4500000"/>
-          </a:xfrm>
-          <a:prstGeom prst="rect">
-            <a:avLst/>
-          </a:prstGeom>
-          <a:noFill/>
-        </p:spPr>
-        <p:txBody>
-          <a:bodyPr wrap="square" lIns="0" rIns="0" tIns="0" bIns="0" anchor="t">
-            <a:spAutoFit/>
-          </a:bodyPr>
-          <a:lstStyle/>
-          <a:p>
-            <a:pPr algn="l">
-              <a:lnSpc>
-                <a:spcPct val="140000"/>
-              </a:lnSpc>
-            </a:pPr>
-            <a:r>
-              <a:rPr sz="1300" b="1">
-                <a:solidFill>
-                  <a:srgbClr val="7B2D26"/>
-                </a:solidFill>
-                <a:latin typeface="Helvetica Neue"/>
-              </a:rPr>
-              <a:t>·  </a:t>
-            </a:r>
-            <a:r>
-              <a:rPr sz="1300">
-                <a:solidFill>
-                  <a:srgbClr val="1F1E1D"/>
-                </a:solidFill>
-                <a:latin typeface="Helvetica Neue"/>
-              </a:rPr>
-              <a:t>Inter-basin water trade</a:t>
-            </a:r>
-          </a:p>
-          <a:p>
-            <a:pPr algn="l">
-              <a:lnSpc>
-                <a:spcPct val="140000"/>
-              </a:lnSpc>
-            </a:pPr>
-            <a:r>
-              <a:rPr sz="1300" b="1">
-                <a:solidFill>
-                  <a:srgbClr val="7B2D26"/>
-                </a:solidFill>
-                <a:latin typeface="Helvetica Neue"/>
-              </a:rPr>
-              <a:t>·  </a:t>
-            </a:r>
-            <a:r>
-              <a:rPr sz="1300">
-                <a:solidFill>
-                  <a:srgbClr val="1F1E1D"/>
-                </a:solidFill>
-                <a:latin typeface="Helvetica Neue"/>
-              </a:rPr>
-              <a:t>Climate-change scenarios (drift in recharge mean)</a:t>
-            </a:r>
-          </a:p>
-          <a:p>
-            <a:pPr algn="l">
-              <a:lnSpc>
-                <a:spcPct val="140000"/>
-              </a:lnSpc>
-            </a:pPr>
-            <a:r>
-              <a:rPr sz="1300" b="1">
-                <a:solidFill>
-                  <a:srgbClr val="7B2D26"/>
-                </a:solidFill>
-                <a:latin typeface="Helvetica Neue"/>
-              </a:rPr>
-              <a:t>·  </a:t>
-            </a:r>
-            <a:r>
-              <a:rPr sz="1300">
-                <a:solidFill>
-                  <a:srgbClr val="1F1E1D"/>
-                </a:solidFill>
-                <a:latin typeface="Helvetica Neue"/>
-              </a:rPr>
-              <a:t>Real permit-process modeling (political delay curves)</a:t>
-            </a:r>
-          </a:p>
-          <a:p>
-            <a:pPr algn="l">
-              <a:lnSpc>
-                <a:spcPct val="140000"/>
-              </a:lnSpc>
-            </a:pPr>
-            <a:r>
-              <a:rPr sz="1300" b="1">
-                <a:solidFill>
-                  <a:srgbClr val="7B2D26"/>
-                </a:solidFill>
-                <a:latin typeface="Helvetica Neue"/>
-              </a:rPr>
-              <a:t>·  </a:t>
-            </a:r>
-            <a:r>
-              <a:rPr sz="1300">
-                <a:solidFill>
-                  <a:srgbClr val="1F1E1D"/>
-                </a:solidFill>
-                <a:latin typeface="Helvetica Neue"/>
-              </a:rPr>
-              <a:t>Inter-operator contestation and bidding</a:t>
-            </a:r>
-          </a:p>
-          <a:p>
-            <a:pPr algn="l">
-              <a:lnSpc>
-                <a:spcPct val="140000"/>
-              </a:lnSpc>
-            </a:pPr>
-            <a:r>
-              <a:rPr sz="1300" b="1">
-                <a:solidFill>
-                  <a:srgbClr val="7B2D26"/>
-                </a:solidFill>
-                <a:latin typeface="Helvetica Neue"/>
-              </a:rPr>
-              <a:t>·  </a:t>
-            </a:r>
-            <a:r>
-              <a:rPr sz="1300">
-                <a:solidFill>
-                  <a:srgbClr val="1F1E1D"/>
-                </a:solidFill>
-                <a:latin typeface="Helvetica Neue"/>
-              </a:rPr>
-              <a:t>Endogenous DC demand response (price / water cost)</a:t>
-            </a:r>
-          </a:p>
-          <a:p>
-            <a:pPr algn="l">
-              <a:lnSpc>
-                <a:spcPct val="140000"/>
-              </a:lnSpc>
-            </a:pPr>
-            <a:r>
-              <a:rPr sz="1300" b="1">
-                <a:solidFill>
-                  <a:srgbClr val="7B2D26"/>
-                </a:solidFill>
-                <a:latin typeface="Helvetica Neue"/>
-              </a:rPr>
-              <a:t>·  </a:t>
-            </a:r>
-            <a:r>
-              <a:rPr sz="1300">
-                <a:solidFill>
-                  <a:srgbClr val="1F1E1D"/>
-                </a:solidFill>
-                <a:latin typeface="Helvetica Neue"/>
-              </a:rPr>
-              <a:t>Calibrate to a real candidate basin (Pacific NW, Chile)</a:t>
-            </a:r>
-          </a:p>
-        </p:txBody>
-      </p:sp>
-      <p:sp>
-        <p:nvSpPr>
-          <p:cNvPr id="8" name="TextBox 7"/>
           <p:cNvSpPr txBox="1"/>
           <p:nvPr/>
         </p:nvSpPr>
@@ -6565,7 +6796,7 @@
       </p:sp>
       <p:sp>
         <p:nvSpPr>
-          <p:cNvPr id="9" name="TextBox 8"/>
+          <p:cNvPr id="8" name="TextBox 7"/>
           <p:cNvSpPr txBox="1"/>
           <p:nvPr/>
         </p:nvSpPr>
@@ -6593,7 +6824,7 @@
                 </a:solidFill>
                 <a:latin typeface="Helvetica Neue"/>
               </a:rPr>
-              <a:t>13 / 14</a:t>
+              <a:t>13 / 15</a:t>
             </a:r>
           </a:p>
         </p:txBody>
@@ -6697,6 +6928,596 @@
                 </a:solidFill>
                 <a:latin typeface="Georgia"/>
               </a:rPr>
+              <a:t>Limitations and Future Work</a:t>
+            </a:r>
+          </a:p>
+        </p:txBody>
+      </p:sp>
+      <p:sp>
+        <p:nvSpPr>
+          <p:cNvPr id="4" name="TextBox 3"/>
+          <p:cNvSpPr txBox="1"/>
+          <p:nvPr/>
+        </p:nvSpPr>
+        <p:spPr>
+          <a:xfrm>
+            <a:off x="700000" y="1800000"/>
+            <a:ext cx="5900000" cy="400000"/>
+          </a:xfrm>
+          <a:prstGeom prst="rect">
+            <a:avLst/>
+          </a:prstGeom>
+          <a:noFill/>
+        </p:spPr>
+        <p:txBody>
+          <a:bodyPr wrap="square" lIns="0" rIns="0" tIns="0" bIns="0" anchor="t">
+            <a:spAutoFit/>
+          </a:bodyPr>
+          <a:lstStyle/>
+          <a:p>
+            <a:pPr algn="l"/>
+            <a:r>
+              <a:rPr sz="1100" b="1" i="0">
+                <a:solidFill>
+                  <a:srgbClr val="7B2D26"/>
+                </a:solidFill>
+                <a:latin typeface="Helvetica Neue"/>
+              </a:rPr>
+              <a:t>LIMITATIONS</a:t>
+            </a:r>
+          </a:p>
+        </p:txBody>
+      </p:sp>
+      <p:sp>
+        <p:nvSpPr>
+          <p:cNvPr id="5" name="TextBox 4"/>
+          <p:cNvSpPr txBox="1"/>
+          <p:nvPr/>
+        </p:nvSpPr>
+        <p:spPr>
+          <a:xfrm>
+            <a:off x="700000" y="2250000"/>
+            <a:ext cx="5900000" cy="4500000"/>
+          </a:xfrm>
+          <a:prstGeom prst="rect">
+            <a:avLst/>
+          </a:prstGeom>
+          <a:noFill/>
+        </p:spPr>
+        <p:txBody>
+          <a:bodyPr wrap="square" lIns="0" rIns="0" tIns="0" bIns="0" anchor="t">
+            <a:spAutoFit/>
+          </a:bodyPr>
+          <a:lstStyle/>
+          <a:p>
+            <a:pPr algn="l">
+              <a:lnSpc>
+                <a:spcPct val="140000"/>
+              </a:lnSpc>
+            </a:pPr>
+            <a:r>
+              <a:rPr sz="1300" b="1">
+                <a:solidFill>
+                  <a:srgbClr val="7B2D26"/>
+                </a:solidFill>
+                <a:latin typeface="Helvetica Neue"/>
+              </a:rPr>
+              <a:t>·  </a:t>
+            </a:r>
+            <a:r>
+              <a:rPr sz="1300">
+                <a:solidFill>
+                  <a:srgbClr val="1F1E1D"/>
+                </a:solidFill>
+                <a:latin typeface="Helvetica Neue"/>
+              </a:rPr>
+              <a:t>Synthetic parameters (calibrated, not validated against a specific basin)</a:t>
+            </a:r>
+          </a:p>
+          <a:p>
+            <a:pPr algn="l">
+              <a:lnSpc>
+                <a:spcPct val="140000"/>
+              </a:lnSpc>
+            </a:pPr>
+            <a:r>
+              <a:rPr sz="1300" b="1">
+                <a:solidFill>
+                  <a:srgbClr val="7B2D26"/>
+                </a:solidFill>
+                <a:latin typeface="Helvetica Neue"/>
+              </a:rPr>
+              <a:t>·  </a:t>
+            </a:r>
+            <a:r>
+              <a:rPr sz="1300">
+                <a:solidFill>
+                  <a:srgbClr val="1F1E1D"/>
+                </a:solidFill>
+                <a:latin typeface="Helvetica Neue"/>
+              </a:rPr>
+              <a:t>No climate-change drift in recharge mean</a:t>
+            </a:r>
+          </a:p>
+          <a:p>
+            <a:pPr algn="l">
+              <a:lnSpc>
+                <a:spcPct val="140000"/>
+              </a:lnSpc>
+            </a:pPr>
+            <a:r>
+              <a:rPr sz="1300" b="1">
+                <a:solidFill>
+                  <a:srgbClr val="7B2D26"/>
+                </a:solidFill>
+                <a:latin typeface="Helvetica Neue"/>
+              </a:rPr>
+              <a:t>·  </a:t>
+            </a:r>
+            <a:r>
+              <a:rPr sz="1300">
+                <a:solidFill>
+                  <a:srgbClr val="1F1E1D"/>
+                </a:solidFill>
+                <a:latin typeface="Helvetica Neue"/>
+              </a:rPr>
+              <a:t>Single basin, no inter-basin trade</a:t>
+            </a:r>
+          </a:p>
+          <a:p>
+            <a:pPr algn="l">
+              <a:lnSpc>
+                <a:spcPct val="140000"/>
+              </a:lnSpc>
+            </a:pPr>
+            <a:r>
+              <a:rPr sz="1300" b="1">
+                <a:solidFill>
+                  <a:srgbClr val="7B2D26"/>
+                </a:solidFill>
+                <a:latin typeface="Helvetica Neue"/>
+              </a:rPr>
+              <a:t>·  </a:t>
+            </a:r>
+            <a:r>
+              <a:rPr sz="1300">
+                <a:solidFill>
+                  <a:srgbClr val="1F1E1D"/>
+                </a:solidFill>
+                <a:latin typeface="Helvetica Neue"/>
+              </a:rPr>
+              <a:t>Regulator has perfect observability after delay</a:t>
+            </a:r>
+          </a:p>
+          <a:p>
+            <a:pPr algn="l">
+              <a:lnSpc>
+                <a:spcPct val="140000"/>
+              </a:lnSpc>
+            </a:pPr>
+            <a:r>
+              <a:rPr sz="1300" b="1">
+                <a:solidFill>
+                  <a:srgbClr val="7B2D26"/>
+                </a:solidFill>
+                <a:latin typeface="Helvetica Neue"/>
+              </a:rPr>
+              <a:t>·  </a:t>
+            </a:r>
+            <a:r>
+              <a:rPr sz="1300">
+                <a:solidFill>
+                  <a:srgbClr val="1F1E1D"/>
+                </a:solidFill>
+                <a:latin typeface="Helvetica Neue"/>
+              </a:rPr>
+              <a:t>DC demand is exogenous (compute growth not price-responsive)</a:t>
+            </a:r>
+          </a:p>
+          <a:p>
+            <a:pPr algn="l">
+              <a:lnSpc>
+                <a:spcPct val="140000"/>
+              </a:lnSpc>
+            </a:pPr>
+            <a:r>
+              <a:rPr sz="1300" b="1">
+                <a:solidFill>
+                  <a:srgbClr val="7B2D26"/>
+                </a:solidFill>
+                <a:latin typeface="Helvetica Neue"/>
+              </a:rPr>
+              <a:t>·  </a:t>
+            </a:r>
+            <a:r>
+              <a:rPr sz="1300">
+                <a:solidFill>
+                  <a:srgbClr val="1F1E1D"/>
+                </a:solidFill>
+                <a:latin typeface="Helvetica Neue"/>
+              </a:rPr>
+              <a:t>Ag yield loss simplified: below threshold = dead</a:t>
+            </a:r>
+          </a:p>
+        </p:txBody>
+      </p:sp>
+      <p:sp>
+        <p:nvSpPr>
+          <p:cNvPr id="6" name="TextBox 5"/>
+          <p:cNvSpPr txBox="1"/>
+          <p:nvPr/>
+        </p:nvSpPr>
+        <p:spPr>
+          <a:xfrm>
+            <a:off x="7100000" y="1800000"/>
+            <a:ext cx="5700000" cy="400000"/>
+          </a:xfrm>
+          <a:prstGeom prst="rect">
+            <a:avLst/>
+          </a:prstGeom>
+          <a:noFill/>
+        </p:spPr>
+        <p:txBody>
+          <a:bodyPr wrap="square" lIns="0" rIns="0" tIns="0" bIns="0" anchor="t">
+            <a:spAutoFit/>
+          </a:bodyPr>
+          <a:lstStyle/>
+          <a:p>
+            <a:pPr algn="l"/>
+            <a:r>
+              <a:rPr sz="1100" b="1" i="0">
+                <a:solidFill>
+                  <a:srgbClr val="7B2D26"/>
+                </a:solidFill>
+                <a:latin typeface="Helvetica Neue"/>
+              </a:rPr>
+              <a:t>FUTURE WORK</a:t>
+            </a:r>
+          </a:p>
+        </p:txBody>
+      </p:sp>
+      <p:sp>
+        <p:nvSpPr>
+          <p:cNvPr id="7" name="TextBox 6"/>
+          <p:cNvSpPr txBox="1"/>
+          <p:nvPr/>
+        </p:nvSpPr>
+        <p:spPr>
+          <a:xfrm>
+            <a:off x="7100000" y="2250000"/>
+            <a:ext cx="5700000" cy="4500000"/>
+          </a:xfrm>
+          <a:prstGeom prst="rect">
+            <a:avLst/>
+          </a:prstGeom>
+          <a:noFill/>
+        </p:spPr>
+        <p:txBody>
+          <a:bodyPr wrap="square" lIns="0" rIns="0" tIns="0" bIns="0" anchor="t">
+            <a:spAutoFit/>
+          </a:bodyPr>
+          <a:lstStyle/>
+          <a:p>
+            <a:pPr algn="l">
+              <a:lnSpc>
+                <a:spcPct val="140000"/>
+              </a:lnSpc>
+            </a:pPr>
+            <a:r>
+              <a:rPr sz="1300" b="1">
+                <a:solidFill>
+                  <a:srgbClr val="7B2D26"/>
+                </a:solidFill>
+                <a:latin typeface="Helvetica Neue"/>
+              </a:rPr>
+              <a:t>·  </a:t>
+            </a:r>
+            <a:r>
+              <a:rPr sz="1300">
+                <a:solidFill>
+                  <a:srgbClr val="1F1E1D"/>
+                </a:solidFill>
+                <a:latin typeface="Helvetica Neue"/>
+              </a:rPr>
+              <a:t>Inter-basin water trade</a:t>
+            </a:r>
+          </a:p>
+          <a:p>
+            <a:pPr algn="l">
+              <a:lnSpc>
+                <a:spcPct val="140000"/>
+              </a:lnSpc>
+            </a:pPr>
+            <a:r>
+              <a:rPr sz="1300" b="1">
+                <a:solidFill>
+                  <a:srgbClr val="7B2D26"/>
+                </a:solidFill>
+                <a:latin typeface="Helvetica Neue"/>
+              </a:rPr>
+              <a:t>·  </a:t>
+            </a:r>
+            <a:r>
+              <a:rPr sz="1300">
+                <a:solidFill>
+                  <a:srgbClr val="1F1E1D"/>
+                </a:solidFill>
+                <a:latin typeface="Helvetica Neue"/>
+              </a:rPr>
+              <a:t>Climate-change scenarios (drift in recharge mean)</a:t>
+            </a:r>
+          </a:p>
+          <a:p>
+            <a:pPr algn="l">
+              <a:lnSpc>
+                <a:spcPct val="140000"/>
+              </a:lnSpc>
+            </a:pPr>
+            <a:r>
+              <a:rPr sz="1300" b="1">
+                <a:solidFill>
+                  <a:srgbClr val="7B2D26"/>
+                </a:solidFill>
+                <a:latin typeface="Helvetica Neue"/>
+              </a:rPr>
+              <a:t>·  </a:t>
+            </a:r>
+            <a:r>
+              <a:rPr sz="1300">
+                <a:solidFill>
+                  <a:srgbClr val="1F1E1D"/>
+                </a:solidFill>
+                <a:latin typeface="Helvetica Neue"/>
+              </a:rPr>
+              <a:t>Real permit-process modeling (political delay curves)</a:t>
+            </a:r>
+          </a:p>
+          <a:p>
+            <a:pPr algn="l">
+              <a:lnSpc>
+                <a:spcPct val="140000"/>
+              </a:lnSpc>
+            </a:pPr>
+            <a:r>
+              <a:rPr sz="1300" b="1">
+                <a:solidFill>
+                  <a:srgbClr val="7B2D26"/>
+                </a:solidFill>
+                <a:latin typeface="Helvetica Neue"/>
+              </a:rPr>
+              <a:t>·  </a:t>
+            </a:r>
+            <a:r>
+              <a:rPr sz="1300">
+                <a:solidFill>
+                  <a:srgbClr val="1F1E1D"/>
+                </a:solidFill>
+                <a:latin typeface="Helvetica Neue"/>
+              </a:rPr>
+              <a:t>Inter-operator contestation and bidding</a:t>
+            </a:r>
+          </a:p>
+          <a:p>
+            <a:pPr algn="l">
+              <a:lnSpc>
+                <a:spcPct val="140000"/>
+              </a:lnSpc>
+            </a:pPr>
+            <a:r>
+              <a:rPr sz="1300" b="1">
+                <a:solidFill>
+                  <a:srgbClr val="7B2D26"/>
+                </a:solidFill>
+                <a:latin typeface="Helvetica Neue"/>
+              </a:rPr>
+              <a:t>·  </a:t>
+            </a:r>
+            <a:r>
+              <a:rPr sz="1300">
+                <a:solidFill>
+                  <a:srgbClr val="1F1E1D"/>
+                </a:solidFill>
+                <a:latin typeface="Helvetica Neue"/>
+              </a:rPr>
+              <a:t>Endogenous DC demand response (price / water cost)</a:t>
+            </a:r>
+          </a:p>
+          <a:p>
+            <a:pPr algn="l">
+              <a:lnSpc>
+                <a:spcPct val="140000"/>
+              </a:lnSpc>
+            </a:pPr>
+            <a:r>
+              <a:rPr sz="1300" b="1">
+                <a:solidFill>
+                  <a:srgbClr val="7B2D26"/>
+                </a:solidFill>
+                <a:latin typeface="Helvetica Neue"/>
+              </a:rPr>
+              <a:t>·  </a:t>
+            </a:r>
+            <a:r>
+              <a:rPr sz="1300">
+                <a:solidFill>
+                  <a:srgbClr val="1F1E1D"/>
+                </a:solidFill>
+                <a:latin typeface="Helvetica Neue"/>
+              </a:rPr>
+              <a:t>Calibrate to a real candidate basin (Pacific NW, Chile)</a:t>
+            </a:r>
+          </a:p>
+        </p:txBody>
+      </p:sp>
+      <p:sp>
+        <p:nvSpPr>
+          <p:cNvPr id="8" name="TextBox 7"/>
+          <p:cNvSpPr txBox="1"/>
+          <p:nvPr/>
+        </p:nvSpPr>
+        <p:spPr>
+          <a:xfrm>
+            <a:off x="700000" y="7120000"/>
+            <a:ext cx="2500000" cy="300000"/>
+          </a:xfrm>
+          <a:prstGeom prst="rect">
+            <a:avLst/>
+          </a:prstGeom>
+          <a:noFill/>
+        </p:spPr>
+        <p:txBody>
+          <a:bodyPr wrap="square" lIns="0" rIns="0" tIns="0" bIns="0" anchor="t">
+            <a:spAutoFit/>
+          </a:bodyPr>
+          <a:lstStyle/>
+          <a:p>
+            <a:pPr algn="l"/>
+            <a:r>
+              <a:rPr sz="900" b="0" i="0">
+                <a:solidFill>
+                  <a:srgbClr val="605E5B"/>
+                </a:solidFill>
+                <a:latin typeface="Helvetica Neue"/>
+              </a:rPr>
+              <a:t>PARCHED</a:t>
+            </a:r>
+          </a:p>
+        </p:txBody>
+      </p:sp>
+      <p:sp>
+        <p:nvSpPr>
+          <p:cNvPr id="9" name="TextBox 8"/>
+          <p:cNvSpPr txBox="1"/>
+          <p:nvPr/>
+        </p:nvSpPr>
+        <p:spPr>
+          <a:xfrm>
+            <a:off x="11133333" y="7120000"/>
+            <a:ext cx="1500000" cy="300000"/>
+          </a:xfrm>
+          <a:prstGeom prst="rect">
+            <a:avLst/>
+          </a:prstGeom>
+          <a:noFill/>
+        </p:spPr>
+        <p:txBody>
+          <a:bodyPr wrap="square" lIns="0" rIns="0" tIns="0" bIns="0" anchor="t">
+            <a:spAutoFit/>
+          </a:bodyPr>
+          <a:lstStyle/>
+          <a:p>
+            <a:pPr algn="r"/>
+            <a:r>
+              <a:rPr sz="900" b="0" i="0">
+                <a:solidFill>
+                  <a:srgbClr val="605E5B"/>
+                </a:solidFill>
+                <a:latin typeface="Helvetica Neue"/>
+              </a:rPr>
+              <a:t>14 / 15</a:t>
+            </a:r>
+          </a:p>
+        </p:txBody>
+      </p:sp>
+    </p:spTree>
+  </p:cSld>
+  <p:clrMapOvr>
+    <a:masterClrMapping/>
+  </p:clrMapOvr>
+</p:sld>
+</file>
+
+<file path=ppt/slides/slide15.xml><?xml version="1.0" encoding="utf-8"?>
+<p:sld xmlns:a="http://schemas.openxmlformats.org/drawingml/2006/main" xmlns:p="http://schemas.openxmlformats.org/presentationml/2006/main" xmlns:r="http://schemas.openxmlformats.org/officeDocument/2006/relationships">
+  <p:cSld>
+    <p:bg>
+      <p:bgPr>
+        <a:solidFill>
+          <a:srgbClr val="FAF9F5"/>
+        </a:solidFill>
+        <a:effectLst/>
+      </p:bgPr>
+    </p:bg>
+    <p:spTree>
+      <p:nvGrpSpPr>
+        <p:cNvPr id="1" name=""/>
+        <p:cNvGrpSpPr/>
+        <p:nvPr/>
+      </p:nvGrpSpPr>
+      <p:grpSpPr/>
+      <p:sp>
+        <p:nvSpPr>
+          <p:cNvPr id="2" name="Rectangle 1"/>
+          <p:cNvSpPr/>
+          <p:nvPr/>
+        </p:nvSpPr>
+        <p:spPr>
+          <a:xfrm>
+            <a:off x="700000" y="705740"/>
+            <a:ext cx="110000" cy="110000"/>
+          </a:xfrm>
+          <a:prstGeom prst="rect">
+            <a:avLst/>
+          </a:prstGeom>
+          <a:solidFill>
+            <a:srgbClr val="7B2D26"/>
+          </a:solidFill>
+          <a:ln>
+            <a:noFill/>
+          </a:ln>
+        </p:spPr>
+        <p:style>
+          <a:lnRef idx="1">
+            <a:schemeClr val="accent1"/>
+          </a:lnRef>
+          <a:fillRef idx="3">
+            <a:schemeClr val="accent1"/>
+          </a:fillRef>
+          <a:effectRef idx="2">
+            <a:schemeClr val="accent1"/>
+          </a:effectRef>
+          <a:fontRef idx="minor">
+            <a:schemeClr val="lt1"/>
+          </a:fontRef>
+        </p:style>
+        <p:txBody>
+          <a:bodyPr rtlCol="0" anchor="ctr"/>
+          <a:lstStyle/>
+          <a:p>
+            <a:pPr algn="ctr"/>
+          </a:p>
+        </p:txBody>
+      </p:sp>
+      <p:sp>
+        <p:nvSpPr>
+          <p:cNvPr id="3" name="TextBox 2"/>
+          <p:cNvSpPr txBox="1"/>
+          <p:nvPr/>
+        </p:nvSpPr>
+        <p:spPr>
+          <a:xfrm>
+            <a:off x="990000" y="500000"/>
+            <a:ext cx="11643333" cy="900000"/>
+          </a:xfrm>
+          <a:prstGeom prst="rect">
+            <a:avLst/>
+          </a:prstGeom>
+          <a:noFill/>
+        </p:spPr>
+        <p:txBody>
+          <a:bodyPr wrap="square" lIns="0" rIns="0" tIns="0" bIns="0" anchor="t">
+            <a:spAutoFit/>
+          </a:bodyPr>
+          <a:lstStyle/>
+          <a:p>
+            <a:pPr algn="l"/>
+            <a:r>
+              <a:rPr sz="3600" b="1" i="0">
+                <a:solidFill>
+                  <a:srgbClr val="1F1E1D"/>
+                </a:solidFill>
+                <a:latin typeface="Georgia"/>
+              </a:rPr>
               <a:t>Conclusion and Q&amp;A</a:t>
             </a:r>
           </a:p>
@@ -6745,7 +7566,7 @@
         </p:nvSpPr>
         <p:spPr>
           <a:xfrm>
-            <a:off x="700000" y="2300000"/>
+            <a:off x="700000" y="2100000"/>
             <a:ext cx="550000" cy="600000"/>
           </a:xfrm>
           <a:prstGeom prst="rect">
@@ -6780,7 +7601,7 @@
         </p:nvSpPr>
         <p:spPr>
           <a:xfrm>
-            <a:off x="1400000" y="2370000"/>
+            <a:off x="1400000" y="2170000"/>
             <a:ext cx="11133333" cy="600000"/>
           </a:xfrm>
           <a:prstGeom prst="rect">
@@ -6815,7 +7636,7 @@
         </p:nvSpPr>
         <p:spPr>
           <a:xfrm>
-            <a:off x="700000" y="3100000"/>
+            <a:off x="700000" y="2800000"/>
             <a:ext cx="550000" cy="600000"/>
           </a:xfrm>
           <a:prstGeom prst="rect">
@@ -6850,7 +7671,7 @@
         </p:nvSpPr>
         <p:spPr>
           <a:xfrm>
-            <a:off x="1400000" y="3170000"/>
+            <a:off x="1400000" y="2870000"/>
             <a:ext cx="11133333" cy="600000"/>
           </a:xfrm>
           <a:prstGeom prst="rect">
@@ -6885,7 +7706,7 @@
         </p:nvSpPr>
         <p:spPr>
           <a:xfrm>
-            <a:off x="700000" y="3900000"/>
+            <a:off x="700000" y="3500000"/>
             <a:ext cx="550000" cy="600000"/>
           </a:xfrm>
           <a:prstGeom prst="rect">
@@ -6920,7 +7741,7 @@
         </p:nvSpPr>
         <p:spPr>
           <a:xfrm>
-            <a:off x="1400000" y="3970000"/>
+            <a:off x="1400000" y="3570000"/>
             <a:ext cx="11133333" cy="600000"/>
           </a:xfrm>
           <a:prstGeom prst="rect">
@@ -6955,8 +7776,78 @@
         </p:nvSpPr>
         <p:spPr>
           <a:xfrm>
+            <a:off x="700000" y="4200000"/>
+            <a:ext cx="550000" cy="600000"/>
+          </a:xfrm>
+          <a:prstGeom prst="rect">
+            <a:avLst/>
+          </a:prstGeom>
+          <a:noFill/>
+        </p:spPr>
+        <p:txBody>
+          <a:bodyPr wrap="square" lIns="0" rIns="0" tIns="0" bIns="0" anchor="t">
+            <a:spAutoFit/>
+          </a:bodyPr>
+          <a:lstStyle/>
+          <a:p>
+            <a:pPr algn="l"/>
+            <a:r>
+              <a:rPr sz="3200" b="1" i="0">
+                <a:solidFill>
+                  <a:srgbClr val="7B2D26"/>
+                </a:solidFill>
+                <a:latin typeface="Georgia"/>
+              </a:rPr>
+              <a:t>4</a:t>
+            </a:r>
+          </a:p>
+        </p:txBody>
+      </p:sp>
+      <p:sp>
+        <p:nvSpPr>
+          <p:cNvPr id="12" name="TextBox 11"/>
+          <p:cNvSpPr txBox="1"/>
+          <p:nvPr/>
+        </p:nvSpPr>
+        <p:spPr>
+          <a:xfrm>
+            <a:off x="1400000" y="4270000"/>
+            <a:ext cx="11133333" cy="600000"/>
+          </a:xfrm>
+          <a:prstGeom prst="rect">
+            <a:avLst/>
+          </a:prstGeom>
+          <a:noFill/>
+        </p:spPr>
+        <p:txBody>
+          <a:bodyPr wrap="square" lIns="0" rIns="0" tIns="0" bIns="0" anchor="t">
+            <a:spAutoFit/>
+          </a:bodyPr>
+          <a:lstStyle/>
+          <a:p>
+            <a:pPr algn="l"/>
+            <a:r>
+              <a:rPr sz="2000" b="1" i="0">
+                <a:solidFill>
+                  <a:srgbClr val="1F1E1D"/>
+                </a:solidFill>
+                <a:latin typeface="Georgia"/>
+              </a:rPr>
+              <a:t>Restoration &gt;= 100% turns data centers into water assets, not liabilities.</a:t>
+            </a:r>
+          </a:p>
+        </p:txBody>
+      </p:sp>
+      <p:sp>
+        <p:nvSpPr>
+          <p:cNvPr id="13" name="TextBox 12"/>
+          <p:cNvSpPr txBox="1"/>
+          <p:nvPr/>
+        </p:nvSpPr>
+        <p:spPr>
+          <a:xfrm>
             <a:off x="700000" y="5050000"/>
-            <a:ext cx="11933333" cy="1000000"/>
+            <a:ext cx="11933333" cy="800000"/>
           </a:xfrm>
           <a:prstGeom prst="rect">
             <a:avLst/>
@@ -6971,26 +7862,26 @@
           <a:p>
             <a:pPr algn="l"/>
             <a:r>
-              <a:rPr sz="2000" b="0" i="1">
+              <a:rPr sz="1700" b="0" i="1">
                 <a:solidFill>
                   <a:srgbClr val="7B2D26"/>
                 </a:solidFill>
                 <a:latin typeface="Georgia"/>
               </a:rPr>
-              <a:t>"If you want to keep the water on, you have to cap the draw before anyone asks you to."</a:t>
-            </a:r>
-          </a:p>
-        </p:txBody>
-      </p:sp>
-      <p:sp>
-        <p:nvSpPr>
-          <p:cNvPr id="12" name="TextBox 11"/>
-          <p:cNvSpPr txBox="1"/>
-          <p:nvPr/>
-        </p:nvSpPr>
-        <p:spPr>
-          <a:xfrm>
-            <a:off x="700000" y="6200000"/>
+              <a:t>"If you want to keep the water on, cap the draw before anyone asks -- or make the data center pay it back."</a:t>
+            </a:r>
+          </a:p>
+        </p:txBody>
+      </p:sp>
+      <p:sp>
+        <p:nvSpPr>
+          <p:cNvPr id="14" name="TextBox 13"/>
+          <p:cNvSpPr txBox="1"/>
+          <p:nvPr/>
+        </p:nvSpPr>
+        <p:spPr>
+          <a:xfrm>
+            <a:off x="700000" y="6000000"/>
             <a:ext cx="11933333" cy="400000"/>
           </a:xfrm>
           <a:prstGeom prst="rect">
@@ -7019,13 +7910,13 @@
       </p:sp>
       <p:sp>
         <p:nvSpPr>
-          <p:cNvPr id="13" name="TextBox 12"/>
-          <p:cNvSpPr txBox="1"/>
-          <p:nvPr/>
-        </p:nvSpPr>
-        <p:spPr>
-          <a:xfrm>
-            <a:off x="700000" y="6600000"/>
+          <p:cNvPr id="15" name="TextBox 14"/>
+          <p:cNvSpPr txBox="1"/>
+          <p:nvPr/>
+        </p:nvSpPr>
+        <p:spPr>
+          <a:xfrm>
+            <a:off x="700000" y="6450000"/>
             <a:ext cx="11933333" cy="400000"/>
           </a:xfrm>
           <a:prstGeom prst="rect">
@@ -7054,7 +7945,7 @@
       </p:sp>
       <p:sp>
         <p:nvSpPr>
-          <p:cNvPr id="14" name="TextBox 13"/>
+          <p:cNvPr id="16" name="TextBox 15"/>
           <p:cNvSpPr txBox="1"/>
           <p:nvPr/>
         </p:nvSpPr>
@@ -7089,7 +7980,7 @@
       </p:sp>
       <p:sp>
         <p:nvSpPr>
-          <p:cNvPr id="15" name="TextBox 14"/>
+          <p:cNvPr id="17" name="TextBox 16"/>
           <p:cNvSpPr txBox="1"/>
           <p:nvPr/>
         </p:nvSpPr>
@@ -7117,7 +8008,7 @@
                 </a:solidFill>
                 <a:latin typeface="Helvetica Neue"/>
               </a:rPr>
-              <a:t>14 / 14</a:t>
+              <a:t>15 / 15</a:t>
             </a:r>
           </a:p>
         </p:txBody>
@@ -7431,7 +8322,7 @@
                 </a:solidFill>
                 <a:latin typeface="Helvetica Neue"/>
               </a:rPr>
-              <a:t>2 / 14</a:t>
+              <a:t>2 / 15</a:t>
             </a:r>
           </a:p>
         </p:txBody>
@@ -7893,7 +8784,7 @@
                 </a:solidFill>
                 <a:latin typeface="Helvetica Neue"/>
               </a:rPr>
-              <a:t>3 / 14</a:t>
+              <a:t>3 / 15</a:t>
             </a:r>
           </a:p>
         </p:txBody>
@@ -8200,7 +9091,7 @@
                 </a:solidFill>
                 <a:latin typeface="Helvetica Neue"/>
               </a:rPr>
-              <a:t>4 / 14</a:t>
+              <a:t>4 / 15</a:t>
             </a:r>
           </a:p>
         </p:txBody>
@@ -8689,7 +9580,7 @@
                 </a:solidFill>
                 <a:latin typeface="Helvetica Neue"/>
               </a:rPr>
-              <a:t>5 / 14</a:t>
+              <a:t>5 / 15</a:t>
             </a:r>
           </a:p>
         </p:txBody>
@@ -9095,7 +9986,7 @@
                 </a:solidFill>
                 <a:latin typeface="Helvetica Neue"/>
               </a:rPr>
-              <a:t>6 / 14</a:t>
+              <a:t>6 / 15</a:t>
             </a:r>
           </a:p>
         </p:txBody>
@@ -9724,7 +10615,7 @@
                 </a:solidFill>
                 <a:latin typeface="Helvetica Neue"/>
               </a:rPr>
-              <a:t>7 / 14</a:t>
+              <a:t>7 / 15</a:t>
             </a:r>
           </a:p>
         </p:txBody>
@@ -10167,7 +11058,7 @@
                 </a:solidFill>
                 <a:latin typeface="Helvetica Neue"/>
               </a:rPr>
-              <a:t>8 / 14</a:t>
+              <a:t>8 / 15</a:t>
             </a:r>
           </a:p>
         </p:txBody>
@@ -10575,7 +11466,7 @@
                 </a:solidFill>
                 <a:latin typeface="Helvetica Neue"/>
               </a:rPr>
-              <a:t>9 / 14</a:t>
+              <a:t>9 / 15</a:t>
             </a:r>
           </a:p>
         </p:txBody>

</xml_diff>